<commit_message>
Add scan offical documents and fix presentation
</commit_message>
<xml_diff>
--- a/Documentation/Official documents/PPTX/Презентация курсовой работы.pptx
+++ b/Documentation/Official documents/PPTX/Презентация курсовой работы.pptx
@@ -19,8 +19,9 @@
     <p:sldId id="265" r:id="rId13"/>
     <p:sldId id="268" r:id="rId14"/>
     <p:sldId id="269" r:id="rId15"/>
-    <p:sldId id="270" r:id="rId16"/>
-    <p:sldId id="271" r:id="rId17"/>
+    <p:sldId id="273" r:id="rId16"/>
+    <p:sldId id="270" r:id="rId17"/>
+    <p:sldId id="271" r:id="rId18"/>
   </p:sldIdLst>
   <p:sldSz cx="12192000" cy="6858000"/>
   <p:notesSz cx="12192000" cy="6858000"/>
@@ -199,7 +200,7 @@
           <a:p>
             <a:fld id="{1D8BD707-D9CF-40AE-B4C6-C98DA3205C09}" type="datetimeFigureOut">
               <a:rPr lang="en-US"/>
-              <a:t>6/3/2026</a:t>
+              <a:t>6/6/2026</a:t>
             </a:fld>
             <a:endParaRPr lang="en-US"/>
           </a:p>
@@ -388,7 +389,7 @@
           <a:p>
             <a:fld id="{1D8BD707-D9CF-40AE-B4C6-C98DA3205C09}" type="datetimeFigureOut">
               <a:rPr lang="en-US"/>
-              <a:t>6/3/2026</a:t>
+              <a:t>6/6/2026</a:t>
             </a:fld>
             <a:endParaRPr lang="en-US"/>
           </a:p>
@@ -614,7 +615,7 @@
           <a:p>
             <a:fld id="{1D8BD707-D9CF-40AE-B4C6-C98DA3205C09}" type="datetimeFigureOut">
               <a:rPr lang="en-US"/>
-              <a:t>6/3/2026</a:t>
+              <a:t>6/6/2026</a:t>
             </a:fld>
             <a:endParaRPr lang="en-US"/>
           </a:p>
@@ -774,7 +775,7 @@
           <a:p>
             <a:fld id="{1D8BD707-D9CF-40AE-B4C6-C98DA3205C09}" type="datetimeFigureOut">
               <a:rPr lang="en-US"/>
-              <a:t>6/3/2026</a:t>
+              <a:t>6/6/2026</a:t>
             </a:fld>
             <a:endParaRPr lang="en-US"/>
           </a:p>
@@ -905,7 +906,7 @@
           <a:p>
             <a:fld id="{1D8BD707-D9CF-40AE-B4C6-C98DA3205C09}" type="datetimeFigureOut">
               <a:rPr lang="en-US"/>
-              <a:t>6/3/2026</a:t>
+              <a:t>6/6/2026</a:t>
             </a:fld>
             <a:endParaRPr lang="en-US"/>
           </a:p>
@@ -1142,7 +1143,7 @@
           <a:p>
             <a:fld id="{1D8BD707-D9CF-40AE-B4C6-C98DA3205C09}" type="datetimeFigureOut">
               <a:rPr lang="en-US"/>
-              <a:t>6/3/2026</a:t>
+              <a:t>6/6/2026</a:t>
             </a:fld>
             <a:endParaRPr lang="en-US"/>
           </a:p>
@@ -1375,161 +1376,6 @@
       </p:grpSpPr>
       <p:sp>
         <p:nvSpPr>
-          <p:cNvPr id="2" name="object 2"/>
-          <p:cNvSpPr txBox="1"/>
-          <p:nvPr/>
-        </p:nvSpPr>
-        <p:spPr>
-          <a:xfrm>
-            <a:off x="1802129" y="1732280"/>
-            <a:ext cx="9046210" cy="2190750"/>
-          </a:xfrm>
-          <a:prstGeom prst="rect">
-            <a:avLst/>
-          </a:prstGeom>
-        </p:spPr>
-        <p:txBody>
-          <a:bodyPr vert="horz" wrap="square" lIns="0" tIns="99695" rIns="0" bIns="0" rtlCol="0">
-            <a:spAutoFit/>
-          </a:bodyPr>
-          <a:lstStyle/>
-          <a:p>
-            <a:pPr marL="2033270" marR="1344930" indent="-1136015">
-              <a:lnSpc>
-                <a:spcPts val="5400"/>
-              </a:lnSpc>
-              <a:spcBef>
-                <a:spcPts val="785"/>
-              </a:spcBef>
-            </a:pPr>
-            <a:r>
-              <a:rPr sz="5000" b="1" dirty="0">
-                <a:latin typeface="Calibri"/>
-                <a:cs typeface="Calibri"/>
-              </a:rPr>
-              <a:t>Разработка</a:t>
-            </a:r>
-            <a:r>
-              <a:rPr sz="5000" b="1" spc="-165" dirty="0">
-                <a:latin typeface="Calibri"/>
-                <a:cs typeface="Calibri"/>
-              </a:rPr>
-              <a:t> </a:t>
-            </a:r>
-            <a:r>
-              <a:rPr sz="5000" b="1" spc="-20" dirty="0">
-                <a:latin typeface="Calibri"/>
-                <a:cs typeface="Calibri"/>
-              </a:rPr>
-              <a:t>кулинарного </a:t>
-            </a:r>
-            <a:r>
-              <a:rPr sz="5000" b="1" spc="-10" dirty="0">
-                <a:latin typeface="Calibri"/>
-                <a:cs typeface="Calibri"/>
-              </a:rPr>
-              <a:t>веб-приложения</a:t>
-            </a:r>
-            <a:endParaRPr sz="5000">
-              <a:latin typeface="Calibri"/>
-              <a:cs typeface="Calibri"/>
-            </a:endParaRPr>
-          </a:p>
-          <a:p>
-            <a:pPr marL="12700">
-              <a:lnSpc>
-                <a:spcPct val="100000"/>
-              </a:lnSpc>
-              <a:spcBef>
-                <a:spcPts val="2920"/>
-              </a:spcBef>
-            </a:pPr>
-            <a:r>
-              <a:rPr sz="2200" dirty="0">
-                <a:latin typeface="Calibri"/>
-                <a:cs typeface="Calibri"/>
-              </a:rPr>
-              <a:t>02.03.02</a:t>
-            </a:r>
-            <a:r>
-              <a:rPr sz="2200" spc="-40" dirty="0">
-                <a:latin typeface="Calibri"/>
-                <a:cs typeface="Calibri"/>
-              </a:rPr>
-              <a:t> </a:t>
-            </a:r>
-            <a:r>
-              <a:rPr sz="2200" spc="-10" dirty="0">
-                <a:latin typeface="Calibri"/>
-                <a:cs typeface="Calibri"/>
-              </a:rPr>
-              <a:t>«Фундаментальная</a:t>
-            </a:r>
-            <a:r>
-              <a:rPr sz="2200" spc="-30" dirty="0">
-                <a:latin typeface="Calibri"/>
-                <a:cs typeface="Calibri"/>
-              </a:rPr>
-              <a:t> </a:t>
-            </a:r>
-            <a:r>
-              <a:rPr sz="2200" spc="-10" dirty="0">
-                <a:latin typeface="Calibri"/>
-                <a:cs typeface="Calibri"/>
-              </a:rPr>
-              <a:t>информатика</a:t>
-            </a:r>
-            <a:r>
-              <a:rPr sz="2200" spc="-20" dirty="0">
-                <a:latin typeface="Calibri"/>
-                <a:cs typeface="Calibri"/>
-              </a:rPr>
-              <a:t> </a:t>
-            </a:r>
-            <a:r>
-              <a:rPr sz="2200" dirty="0">
-                <a:latin typeface="Calibri"/>
-                <a:cs typeface="Calibri"/>
-              </a:rPr>
-              <a:t>и</a:t>
-            </a:r>
-            <a:r>
-              <a:rPr sz="2200" spc="-25" dirty="0">
-                <a:latin typeface="Calibri"/>
-                <a:cs typeface="Calibri"/>
-              </a:rPr>
-              <a:t> </a:t>
-            </a:r>
-            <a:r>
-              <a:rPr sz="2200" spc="-10" dirty="0">
-                <a:latin typeface="Calibri"/>
-                <a:cs typeface="Calibri"/>
-              </a:rPr>
-              <a:t>информационные</a:t>
-            </a:r>
-            <a:r>
-              <a:rPr sz="2200" spc="-20" dirty="0">
-                <a:latin typeface="Calibri"/>
-                <a:cs typeface="Calibri"/>
-              </a:rPr>
-              <a:t> </a:t>
-            </a:r>
-            <a:r>
-              <a:rPr sz="2200" spc="-10" dirty="0">
-                <a:latin typeface="Calibri"/>
-                <a:cs typeface="Calibri"/>
-              </a:rPr>
-              <a:t>технологии»</a:t>
-            </a:r>
-            <a:endParaRPr sz="2200">
-              <a:latin typeface="Calibri"/>
-              <a:cs typeface="Calibri"/>
-            </a:endParaRPr>
-          </a:p>
-        </p:txBody>
-      </p:sp>
-      <p:sp>
-        <p:nvSpPr>
           <p:cNvPr id="3" name="object 3"/>
           <p:cNvSpPr txBox="1"/>
           <p:nvPr/>
@@ -2227,6 +2073,272 @@
             <a:endParaRPr sz="2200">
               <a:latin typeface="Calibri"/>
               <a:cs typeface="Calibri"/>
+            </a:endParaRPr>
+          </a:p>
+        </p:txBody>
+      </p:sp>
+      <p:sp>
+        <p:nvSpPr>
+          <p:cNvPr id="7" name="TextBox 6"/>
+          <p:cNvSpPr txBox="1">
+            <a:spLocks noChangeArrowheads="1"/>
+          </p:cNvSpPr>
+          <p:nvPr/>
+        </p:nvSpPr>
+        <p:spPr bwMode="auto">
+          <a:xfrm>
+            <a:off x="1462087" y="3635227"/>
+            <a:ext cx="9267825" cy="430887"/>
+          </a:xfrm>
+          <a:prstGeom prst="rect">
+            <a:avLst/>
+          </a:prstGeom>
+          <a:noFill/>
+          <a:ln>
+            <a:noFill/>
+          </a:ln>
+          <a:extLst>
+            <a:ext uri="{909E8E84-426E-40DD-AFC4-6F175D3DCCD1}">
+              <a14:hiddenFill xmlns:a14="http://schemas.microsoft.com/office/drawing/2010/main">
+                <a:solidFill>
+                  <a:srgbClr val="FFFFFF"/>
+                </a:solidFill>
+              </a14:hiddenFill>
+            </a:ext>
+            <a:ext uri="{91240B29-F687-4F45-9708-019B960494DF}">
+              <a14:hiddenLine xmlns:a14="http://schemas.microsoft.com/office/drawing/2010/main" w="9525">
+                <a:solidFill>
+                  <a:srgbClr val="000000"/>
+                </a:solidFill>
+                <a:miter lim="800000"/>
+                <a:headEnd/>
+                <a:tailEnd/>
+              </a14:hiddenLine>
+            </a:ext>
+          </a:extLst>
+        </p:spPr>
+        <p:txBody>
+          <a:bodyPr wrap="square">
+            <a:spAutoFit/>
+          </a:bodyPr>
+          <a:lstStyle>
+            <a:lvl1pPr>
+              <a:lnSpc>
+                <a:spcPct val="90000"/>
+              </a:lnSpc>
+              <a:spcBef>
+                <a:spcPts val="1000"/>
+              </a:spcBef>
+              <a:buFont typeface="Arial" panose="020B0604020202020204" pitchFamily="34" charset="0"/>
+              <a:buChar char="•"/>
+              <a:defRPr sz="2800">
+                <a:solidFill>
+                  <a:schemeClr val="tx1"/>
+                </a:solidFill>
+                <a:latin typeface="Calibri" panose="020F0502020204030204" pitchFamily="34" charset="0"/>
+              </a:defRPr>
+            </a:lvl1pPr>
+            <a:lvl2pPr marL="742950" indent="-285750">
+              <a:lnSpc>
+                <a:spcPct val="90000"/>
+              </a:lnSpc>
+              <a:spcBef>
+                <a:spcPts val="500"/>
+              </a:spcBef>
+              <a:buFont typeface="Arial" panose="020B0604020202020204" pitchFamily="34" charset="0"/>
+              <a:buChar char="•"/>
+              <a:defRPr sz="2400">
+                <a:solidFill>
+                  <a:schemeClr val="tx1"/>
+                </a:solidFill>
+                <a:latin typeface="Calibri" panose="020F0502020204030204" pitchFamily="34" charset="0"/>
+              </a:defRPr>
+            </a:lvl2pPr>
+            <a:lvl3pPr marL="1143000" indent="-228600">
+              <a:lnSpc>
+                <a:spcPct val="90000"/>
+              </a:lnSpc>
+              <a:spcBef>
+                <a:spcPts val="500"/>
+              </a:spcBef>
+              <a:buFont typeface="Arial" panose="020B0604020202020204" pitchFamily="34" charset="0"/>
+              <a:buChar char="•"/>
+              <a:defRPr sz="2000">
+                <a:solidFill>
+                  <a:schemeClr val="tx1"/>
+                </a:solidFill>
+                <a:latin typeface="Calibri" panose="020F0502020204030204" pitchFamily="34" charset="0"/>
+              </a:defRPr>
+            </a:lvl3pPr>
+            <a:lvl4pPr marL="1600200" indent="-228600">
+              <a:lnSpc>
+                <a:spcPct val="90000"/>
+              </a:lnSpc>
+              <a:spcBef>
+                <a:spcPts val="500"/>
+              </a:spcBef>
+              <a:buFont typeface="Arial" panose="020B0604020202020204" pitchFamily="34" charset="0"/>
+              <a:buChar char="•"/>
+              <a:defRPr>
+                <a:solidFill>
+                  <a:schemeClr val="tx1"/>
+                </a:solidFill>
+                <a:latin typeface="Calibri" panose="020F0502020204030204" pitchFamily="34" charset="0"/>
+              </a:defRPr>
+            </a:lvl4pPr>
+            <a:lvl5pPr marL="2057400" indent="-228600">
+              <a:lnSpc>
+                <a:spcPct val="90000"/>
+              </a:lnSpc>
+              <a:spcBef>
+                <a:spcPts val="500"/>
+              </a:spcBef>
+              <a:buFont typeface="Arial" panose="020B0604020202020204" pitchFamily="34" charset="0"/>
+              <a:buChar char="•"/>
+              <a:defRPr>
+                <a:solidFill>
+                  <a:schemeClr val="tx1"/>
+                </a:solidFill>
+                <a:latin typeface="Calibri" panose="020F0502020204030204" pitchFamily="34" charset="0"/>
+              </a:defRPr>
+            </a:lvl5pPr>
+            <a:lvl6pPr marL="2514600" indent="-228600" defTabSz="457200" eaLnBrk="0" fontAlgn="base" hangingPunct="0">
+              <a:lnSpc>
+                <a:spcPct val="90000"/>
+              </a:lnSpc>
+              <a:spcBef>
+                <a:spcPts val="500"/>
+              </a:spcBef>
+              <a:spcAft>
+                <a:spcPct val="0"/>
+              </a:spcAft>
+              <a:buFont typeface="Arial" panose="020B0604020202020204" pitchFamily="34" charset="0"/>
+              <a:buChar char="•"/>
+              <a:defRPr>
+                <a:solidFill>
+                  <a:schemeClr val="tx1"/>
+                </a:solidFill>
+                <a:latin typeface="Calibri" panose="020F0502020204030204" pitchFamily="34" charset="0"/>
+              </a:defRPr>
+            </a:lvl6pPr>
+            <a:lvl7pPr marL="2971800" indent="-228600" defTabSz="457200" eaLnBrk="0" fontAlgn="base" hangingPunct="0">
+              <a:lnSpc>
+                <a:spcPct val="90000"/>
+              </a:lnSpc>
+              <a:spcBef>
+                <a:spcPts val="500"/>
+              </a:spcBef>
+              <a:spcAft>
+                <a:spcPct val="0"/>
+              </a:spcAft>
+              <a:buFont typeface="Arial" panose="020B0604020202020204" pitchFamily="34" charset="0"/>
+              <a:buChar char="•"/>
+              <a:defRPr>
+                <a:solidFill>
+                  <a:schemeClr val="tx1"/>
+                </a:solidFill>
+                <a:latin typeface="Calibri" panose="020F0502020204030204" pitchFamily="34" charset="0"/>
+              </a:defRPr>
+            </a:lvl7pPr>
+            <a:lvl8pPr marL="3429000" indent="-228600" defTabSz="457200" eaLnBrk="0" fontAlgn="base" hangingPunct="0">
+              <a:lnSpc>
+                <a:spcPct val="90000"/>
+              </a:lnSpc>
+              <a:spcBef>
+                <a:spcPts val="500"/>
+              </a:spcBef>
+              <a:spcAft>
+                <a:spcPct val="0"/>
+              </a:spcAft>
+              <a:buFont typeface="Arial" panose="020B0604020202020204" pitchFamily="34" charset="0"/>
+              <a:buChar char="•"/>
+              <a:defRPr>
+                <a:solidFill>
+                  <a:schemeClr val="tx1"/>
+                </a:solidFill>
+                <a:latin typeface="Calibri" panose="020F0502020204030204" pitchFamily="34" charset="0"/>
+              </a:defRPr>
+            </a:lvl8pPr>
+            <a:lvl9pPr marL="3886200" indent="-228600" defTabSz="457200" eaLnBrk="0" fontAlgn="base" hangingPunct="0">
+              <a:lnSpc>
+                <a:spcPct val="90000"/>
+              </a:lnSpc>
+              <a:spcBef>
+                <a:spcPts val="500"/>
+              </a:spcBef>
+              <a:spcAft>
+                <a:spcPct val="0"/>
+              </a:spcAft>
+              <a:buFont typeface="Arial" panose="020B0604020202020204" pitchFamily="34" charset="0"/>
+              <a:buChar char="•"/>
+              <a:defRPr>
+                <a:solidFill>
+                  <a:schemeClr val="tx1"/>
+                </a:solidFill>
+                <a:latin typeface="Calibri" panose="020F0502020204030204" pitchFamily="34" charset="0"/>
+              </a:defRPr>
+            </a:lvl9pPr>
+          </a:lstStyle>
+          <a:p>
+            <a:pPr algn="ctr" eaLnBrk="1" hangingPunct="1">
+              <a:lnSpc>
+                <a:spcPct val="100000"/>
+              </a:lnSpc>
+              <a:spcBef>
+                <a:spcPct val="0"/>
+              </a:spcBef>
+              <a:buFontTx/>
+              <a:buNone/>
+            </a:pPr>
+            <a:r>
+              <a:rPr lang="ru-RU" altLang="zh-CN" sz="2200" dirty="0"/>
+              <a:t>02.03.02 «Фундаментальная информатика и информационные технологии»</a:t>
+            </a:r>
+          </a:p>
+        </p:txBody>
+      </p:sp>
+      <p:sp>
+        <p:nvSpPr>
+          <p:cNvPr id="8" name="Заголовок 1"/>
+          <p:cNvSpPr txBox="1">
+            <a:spLocks noChangeArrowheads="1"/>
+          </p:cNvSpPr>
+          <p:nvPr/>
+        </p:nvSpPr>
+        <p:spPr>
+          <a:xfrm>
+            <a:off x="1219200" y="1905000"/>
+            <a:ext cx="9753600" cy="1344612"/>
+          </a:xfrm>
+          <a:prstGeom prst="rect">
+            <a:avLst/>
+          </a:prstGeom>
+        </p:spPr>
+        <p:txBody>
+          <a:bodyPr/>
+          <a:lstStyle>
+            <a:lvl1pPr>
+              <a:defRPr>
+                <a:latin typeface="+mj-lt"/>
+                <a:ea typeface="+mj-ea"/>
+                <a:cs typeface="+mj-cs"/>
+              </a:defRPr>
+            </a:lvl1pPr>
+          </a:lstStyle>
+          <a:p>
+            <a:pPr algn="ctr">
+              <a:defRPr/>
+            </a:pPr>
+            <a:r>
+              <a:rPr lang="ru-RU" altLang="zh-CN" sz="3600" b="1" dirty="0" smtClean="0">
+                <a:latin typeface="+mn-lt"/>
+                <a:cs typeface="等线 Light"/>
+              </a:rPr>
+              <a:t>Разработка приложения для решения задач по идентификации объектов на изображениях </a:t>
+            </a:r>
+            <a:endParaRPr lang="ru-RU" altLang="zh-CN" sz="3600" b="1" dirty="0">
+              <a:latin typeface="+mn-lt"/>
+              <a:cs typeface="等线 Light"/>
             </a:endParaRPr>
           </a:p>
         </p:txBody>
@@ -2410,6 +2522,35 @@
           </a:p>
         </p:txBody>
       </p:sp>
+      <p:pic>
+        <p:nvPicPr>
+          <p:cNvPr id="3" name="Рисунок 2"/>
+          <p:cNvPicPr>
+            <a:picLocks noChangeAspect="1"/>
+          </p:cNvPicPr>
+          <p:nvPr/>
+        </p:nvPicPr>
+        <p:blipFill>
+          <a:blip r:embed="rId2"/>
+          <a:stretch>
+            <a:fillRect/>
+          </a:stretch>
+        </p:blipFill>
+        <p:spPr>
+          <a:xfrm>
+            <a:off x="2514600" y="912108"/>
+            <a:ext cx="7086600" cy="5207085"/>
+          </a:xfrm>
+          <a:prstGeom prst="rect">
+            <a:avLst/>
+          </a:prstGeom>
+          <a:ln w="12700">
+            <a:solidFill>
+              <a:schemeClr val="tx1"/>
+            </a:solidFill>
+          </a:ln>
+        </p:spPr>
+      </p:pic>
     </p:spTree>
     <p:extLst>
       <p:ext uri="{BB962C8B-B14F-4D97-AF65-F5344CB8AC3E}">
@@ -2590,6 +2731,34 @@
           </a:p>
         </p:txBody>
       </p:sp>
+      <p:pic>
+        <p:nvPicPr>
+          <p:cNvPr id="9" name="Рисунок 8"/>
+          <p:cNvPicPr>
+            <a:picLocks noChangeAspect="1"/>
+          </p:cNvPicPr>
+          <p:nvPr/>
+        </p:nvPicPr>
+        <p:blipFill rotWithShape="1">
+          <a:blip r:embed="rId2"/>
+          <a:srcRect/>
+          <a:stretch/>
+        </p:blipFill>
+        <p:spPr>
+          <a:xfrm>
+            <a:off x="1219200" y="1066800"/>
+            <a:ext cx="9720000" cy="4865541"/>
+          </a:xfrm>
+          <a:prstGeom prst="rect">
+            <a:avLst/>
+          </a:prstGeom>
+          <a:ln w="12700">
+            <a:solidFill>
+              <a:schemeClr val="tx1"/>
+            </a:solidFill>
+          </a:ln>
+        </p:spPr>
+      </p:pic>
     </p:spTree>
   </p:cSld>
   <p:clrMapOvr>
@@ -2765,6 +2934,35 @@
           </a:p>
         </p:txBody>
       </p:sp>
+      <p:pic>
+        <p:nvPicPr>
+          <p:cNvPr id="3" name="Рисунок 2"/>
+          <p:cNvPicPr>
+            <a:picLocks noChangeAspect="1"/>
+          </p:cNvPicPr>
+          <p:nvPr/>
+        </p:nvPicPr>
+        <p:blipFill>
+          <a:blip r:embed="rId2"/>
+          <a:stretch>
+            <a:fillRect/>
+          </a:stretch>
+        </p:blipFill>
+        <p:spPr>
+          <a:xfrm>
+            <a:off x="1371600" y="1143000"/>
+            <a:ext cx="9593450" cy="4572000"/>
+          </a:xfrm>
+          <a:prstGeom prst="rect">
+            <a:avLst/>
+          </a:prstGeom>
+          <a:ln w="28575">
+            <a:solidFill>
+              <a:schemeClr val="tx1"/>
+            </a:solidFill>
+          </a:ln>
+        </p:spPr>
+      </p:pic>
     </p:spTree>
   </p:cSld>
   <p:clrMapOvr>
@@ -2861,7 +3059,7 @@
         </p:nvGraphicFramePr>
         <p:xfrm>
           <a:off x="831850" y="821817"/>
-          <a:ext cx="10515599" cy="5454534"/>
+          <a:ext cx="10515599" cy="5461582"/>
         </p:xfrm>
         <a:graphic>
           <a:graphicData uri="http://schemas.openxmlformats.org/drawingml/2006/table">
@@ -4578,11 +4776,7 @@
             </a:pPr>
             <a:r>
               <a:rPr lang="ru-RU" dirty="0" smtClean="0"/>
-              <a:t>Проведен </a:t>
-            </a:r>
-            <a:r>
-              <a:rPr lang="ru-RU" dirty="0" smtClean="0"/>
-              <a:t>анализ </a:t>
+              <a:t>Проведен анализ </a:t>
             </a:r>
             <a:r>
               <a:rPr lang="ru-RU" dirty="0"/>
@@ -4675,11 +4869,7 @@
             </a:r>
             <a:r>
               <a:rPr lang="ru-RU" spc="-10" dirty="0" smtClean="0"/>
-              <a:t>десктопное </a:t>
-            </a:r>
-            <a:r>
-              <a:rPr lang="ru-RU" spc="-10" dirty="0" smtClean="0"/>
-              <a:t>приложение</a:t>
+              <a:t>десктопное приложение</a:t>
             </a:r>
             <a:r>
               <a:rPr spc="-10" dirty="0" smtClean="0"/>
@@ -4861,6 +5051,10 @@
           </p:nvPr>
         </p:nvSpPr>
         <p:spPr>
+          <a:xfrm>
+            <a:off x="3505200" y="228600"/>
+            <a:ext cx="4724400" cy="1046175"/>
+          </a:xfrm>
           <a:prstGeom prst="rect">
             <a:avLst/>
           </a:prstGeom>
@@ -4871,13 +5065,167 @@
           </a:bodyPr>
           <a:lstStyle/>
           <a:p>
-            <a:pPr marL="2027555">
+            <a:pPr algn="ctr">
               <a:lnSpc>
                 <a:spcPct val="100000"/>
               </a:lnSpc>
               <a:spcBef>
                 <a:spcPts val="100"/>
               </a:spcBef>
+            </a:pPr>
+            <a:r>
+              <a:rPr lang="ru-RU" dirty="0" smtClean="0"/>
+              <a:t>Таблица </a:t>
+            </a:r>
+            <a:r>
+              <a:rPr lang="en-US" dirty="0" smtClean="0"/>
+              <a:t>SQLite</a:t>
+            </a:r>
+            <a:endParaRPr spc="-105" dirty="0"/>
+          </a:p>
+        </p:txBody>
+      </p:sp>
+      <p:pic>
+        <p:nvPicPr>
+          <p:cNvPr id="6" name="Рисунок 5"/>
+          <p:cNvPicPr>
+            <a:picLocks noChangeAspect="1"/>
+          </p:cNvPicPr>
+          <p:nvPr/>
+        </p:nvPicPr>
+        <p:blipFill>
+          <a:blip r:embed="rId2"/>
+          <a:stretch>
+            <a:fillRect/>
+          </a:stretch>
+        </p:blipFill>
+        <p:spPr>
+          <a:xfrm>
+            <a:off x="1775809" y="1657102"/>
+            <a:ext cx="8640381" cy="3543795"/>
+          </a:xfrm>
+          <a:prstGeom prst="rect">
+            <a:avLst/>
+          </a:prstGeom>
+          <a:ln w="12700">
+            <a:solidFill>
+              <a:schemeClr val="tx1"/>
+            </a:solidFill>
+          </a:ln>
+        </p:spPr>
+      </p:pic>
+      <p:sp>
+        <p:nvSpPr>
+          <p:cNvPr id="7" name="Прямоугольник 6"/>
+          <p:cNvSpPr/>
+          <p:nvPr/>
+        </p:nvSpPr>
+        <p:spPr>
+          <a:xfrm>
+            <a:off x="831850" y="6378218"/>
+            <a:ext cx="4425950" cy="323165"/>
+          </a:xfrm>
+          <a:prstGeom prst="rect">
+            <a:avLst/>
+          </a:prstGeom>
+        </p:spPr>
+        <p:txBody>
+          <a:bodyPr wrap="square">
+            <a:spAutoFit/>
+          </a:bodyPr>
+          <a:lstStyle/>
+          <a:p>
+            <a:pPr marL="12700">
+              <a:lnSpc>
+                <a:spcPts val="1810"/>
+              </a:lnSpc>
+            </a:pPr>
+            <a:r>
+              <a:rPr lang="en-US" spc="-20" dirty="0">
+                <a:solidFill>
+                  <a:srgbClr val="767676"/>
+                </a:solidFill>
+                <a:latin typeface="Calibri"/>
+                <a:cs typeface="Calibri"/>
+              </a:rPr>
+              <a:t>https://github.com/GFooX9/CourseWork2026</a:t>
+            </a:r>
+            <a:endParaRPr lang="ru-RU" spc="-20" dirty="0">
+              <a:solidFill>
+                <a:srgbClr val="767676"/>
+              </a:solidFill>
+              <a:latin typeface="Calibri"/>
+              <a:cs typeface="Calibri"/>
+            </a:endParaRPr>
+          </a:p>
+        </p:txBody>
+      </p:sp>
+    </p:spTree>
+    <p:extLst>
+      <p:ext uri="{BB962C8B-B14F-4D97-AF65-F5344CB8AC3E}">
+        <p14:creationId xmlns:p14="http://schemas.microsoft.com/office/powerpoint/2010/main" val="1330314083"/>
+      </p:ext>
+    </p:extLst>
+  </p:cSld>
+  <p:clrMapOvr>
+    <a:masterClrMapping/>
+  </p:clrMapOvr>
+  <p:timing>
+    <p:tnLst>
+      <p:par>
+        <p:cTn id="1" dur="indefinite" restart="never" nodeType="tmRoot"/>
+      </p:par>
+    </p:tnLst>
+  </p:timing>
+</p:sld>
+</file>
+
+<file path=ppt/slides/slide16.xml><?xml version="1.0" encoding="utf-8"?>
+<p:sld xmlns:a="http://schemas.openxmlformats.org/drawingml/2006/main" xmlns:r="http://schemas.openxmlformats.org/officeDocument/2006/relationships" xmlns:p="http://schemas.openxmlformats.org/presentationml/2006/main" showMasterSp="0">
+  <p:cSld>
+    <p:spTree>
+      <p:nvGrpSpPr>
+        <p:cNvPr id="1" name=""/>
+        <p:cNvGrpSpPr/>
+        <p:nvPr/>
+      </p:nvGrpSpPr>
+      <p:grpSpPr>
+        <a:xfrm>
+          <a:off x="0" y="0"/>
+          <a:ext cx="0" cy="0"/>
+          <a:chOff x="0" y="0"/>
+          <a:chExt cx="0" cy="0"/>
+        </a:xfrm>
+      </p:grpSpPr>
+      <p:sp>
+        <p:nvSpPr>
+          <p:cNvPr id="3" name="object 3"/>
+          <p:cNvSpPr txBox="1">
+            <a:spLocks noGrp="1"/>
+          </p:cNvSpPr>
+          <p:nvPr>
+            <p:ph type="title"/>
+          </p:nvPr>
+        </p:nvSpPr>
+        <p:spPr>
+          <a:xfrm>
+            <a:off x="1655445" y="-304800"/>
+            <a:ext cx="8881109" cy="1046175"/>
+          </a:xfrm>
+          <a:prstGeom prst="rect">
+            <a:avLst/>
+          </a:prstGeom>
+        </p:spPr>
+        <p:txBody>
+          <a:bodyPr vert="horz" wrap="square" lIns="0" tIns="484200" rIns="0" bIns="0" rtlCol="0">
+            <a:spAutoFit/>
+          </a:bodyPr>
+          <a:lstStyle/>
+          <a:p>
+            <a:pPr marL="2027555">
+              <a:lnSpc>
+                <a:spcPct val="100000"/>
+              </a:lnSpc>
             </a:pPr>
             <a:r>
               <a:rPr lang="ru-RU" dirty="0" smtClean="0"/>
@@ -4913,14 +5261,65 @@
         </p:blipFill>
         <p:spPr>
           <a:xfrm>
-            <a:off x="1655445" y="1259027"/>
+            <a:off x="1655445" y="969651"/>
             <a:ext cx="8848452" cy="5395867"/>
           </a:xfrm>
           <a:prstGeom prst="rect">
             <a:avLst/>
           </a:prstGeom>
+          <a:ln w="12700">
+            <a:solidFill>
+              <a:schemeClr val="tx1"/>
+            </a:solidFill>
+          </a:ln>
         </p:spPr>
       </p:pic>
+      <p:sp>
+        <p:nvSpPr>
+          <p:cNvPr id="4" name="Прямоугольник 3"/>
+          <p:cNvSpPr/>
+          <p:nvPr/>
+        </p:nvSpPr>
+        <p:spPr>
+          <a:xfrm>
+            <a:off x="831850" y="6378218"/>
+            <a:ext cx="4425950" cy="323165"/>
+          </a:xfrm>
+          <a:prstGeom prst="rect">
+            <a:avLst/>
+          </a:prstGeom>
+        </p:spPr>
+        <p:txBody>
+          <a:bodyPr wrap="square">
+            <a:spAutoFit/>
+          </a:bodyPr>
+          <a:lstStyle/>
+          <a:p>
+            <a:pPr marL="12700">
+              <a:lnSpc>
+                <a:spcPts val="1810"/>
+              </a:lnSpc>
+            </a:pPr>
+            <a:r>
+              <a:rPr lang="en-US" spc="-20" dirty="0">
+                <a:solidFill>
+                  <a:srgbClr val="767676"/>
+                </a:solidFill>
+                <a:latin typeface="Calibri"/>
+                <a:cs typeface="Calibri"/>
+              </a:rPr>
+              <a:t>https://github.com/GFooX9/CourseWork2026</a:t>
+            </a:r>
+            <a:endParaRPr lang="ru-RU" spc="-20" dirty="0">
+              <a:solidFill>
+                <a:srgbClr val="767676"/>
+              </a:solidFill>
+              <a:latin typeface="Calibri"/>
+              <a:cs typeface="Calibri"/>
+            </a:endParaRPr>
+          </a:p>
+        </p:txBody>
+      </p:sp>
     </p:spTree>
     <p:extLst>
       <p:ext uri="{BB962C8B-B14F-4D97-AF65-F5344CB8AC3E}">
@@ -4941,7 +5340,7 @@
 </p:sld>
 </file>
 
-<file path=ppt/slides/slide16.xml><?xml version="1.0" encoding="utf-8"?>
+<file path=ppt/slides/slide17.xml><?xml version="1.0" encoding="utf-8"?>
 <p:sld xmlns:a="http://schemas.openxmlformats.org/drawingml/2006/main" xmlns:r="http://schemas.openxmlformats.org/officeDocument/2006/relationships" xmlns:p="http://schemas.openxmlformats.org/presentationml/2006/main" showMasterSp="0">
   <p:cSld>
     <p:spTree>
@@ -5057,6 +5456,52 @@
           </a:ln>
         </p:spPr>
       </p:pic>
+      <p:sp>
+        <p:nvSpPr>
+          <p:cNvPr id="6" name="Прямоугольник 5"/>
+          <p:cNvSpPr/>
+          <p:nvPr/>
+        </p:nvSpPr>
+        <p:spPr>
+          <a:xfrm>
+            <a:off x="831850" y="6378218"/>
+            <a:ext cx="4425950" cy="323165"/>
+          </a:xfrm>
+          <a:prstGeom prst="rect">
+            <a:avLst/>
+          </a:prstGeom>
+        </p:spPr>
+        <p:txBody>
+          <a:bodyPr wrap="square">
+            <a:spAutoFit/>
+          </a:bodyPr>
+          <a:lstStyle/>
+          <a:p>
+            <a:pPr marL="12700">
+              <a:lnSpc>
+                <a:spcPts val="1810"/>
+              </a:lnSpc>
+            </a:pPr>
+            <a:r>
+              <a:rPr lang="en-US" spc="-20" dirty="0">
+                <a:solidFill>
+                  <a:srgbClr val="767676"/>
+                </a:solidFill>
+                <a:latin typeface="Calibri"/>
+                <a:cs typeface="Calibri"/>
+              </a:rPr>
+              <a:t>https://github.com/GFooX9/CourseWork2026</a:t>
+            </a:r>
+            <a:endParaRPr lang="ru-RU" spc="-20" dirty="0">
+              <a:solidFill>
+                <a:srgbClr val="767676"/>
+              </a:solidFill>
+              <a:latin typeface="Calibri"/>
+              <a:cs typeface="Calibri"/>
+            </a:endParaRPr>
+          </a:p>
+        </p:txBody>
+      </p:sp>
     </p:spTree>
     <p:extLst>
       <p:ext uri="{BB962C8B-B14F-4D97-AF65-F5344CB8AC3E}">
@@ -5159,7 +5604,7 @@
         </p:nvSpPr>
         <p:spPr>
           <a:xfrm>
-            <a:off x="916937" y="1433173"/>
+            <a:off x="916937" y="1334488"/>
             <a:ext cx="10208261" cy="5059718"/>
           </a:xfrm>
           <a:prstGeom prst="rect">
@@ -5472,6 +5917,52 @@
               <a:t>/14</a:t>
             </a:r>
             <a:endParaRPr spc="-20" dirty="0">
+              <a:solidFill>
+                <a:srgbClr val="767676"/>
+              </a:solidFill>
+              <a:latin typeface="Calibri"/>
+              <a:cs typeface="Calibri"/>
+            </a:endParaRPr>
+          </a:p>
+        </p:txBody>
+      </p:sp>
+      <p:sp>
+        <p:nvSpPr>
+          <p:cNvPr id="5" name="Прямоугольник 4"/>
+          <p:cNvSpPr/>
+          <p:nvPr/>
+        </p:nvSpPr>
+        <p:spPr>
+          <a:xfrm>
+            <a:off x="831850" y="6378218"/>
+            <a:ext cx="4425950" cy="323165"/>
+          </a:xfrm>
+          <a:prstGeom prst="rect">
+            <a:avLst/>
+          </a:prstGeom>
+        </p:spPr>
+        <p:txBody>
+          <a:bodyPr wrap="square">
+            <a:spAutoFit/>
+          </a:bodyPr>
+          <a:lstStyle/>
+          <a:p>
+            <a:pPr marL="12700">
+              <a:lnSpc>
+                <a:spcPts val="1810"/>
+              </a:lnSpc>
+            </a:pPr>
+            <a:r>
+              <a:rPr lang="en-US" spc="-20" dirty="0">
+                <a:solidFill>
+                  <a:srgbClr val="767676"/>
+                </a:solidFill>
+                <a:latin typeface="Calibri"/>
+                <a:cs typeface="Calibri"/>
+              </a:rPr>
+              <a:t>https://github.com/GFooX9/CourseWork2026</a:t>
+            </a:r>
+            <a:endParaRPr lang="ru-RU" spc="-20" dirty="0">
               <a:solidFill>
                 <a:srgbClr val="767676"/>
               </a:solidFill>
@@ -5644,20 +6135,6 @@
               </a:rPr>
               <a:t>Технологический фактор: Экспоненциальный рост визуальных данных требует автоматизации детекции в реальном времени.</a:t>
             </a:r>
-            <a:r>
-              <a:rPr sz="2200" spc="-25" dirty="0" smtClean="0">
-                <a:latin typeface="Calibri"/>
-                <a:cs typeface="Calibri"/>
-              </a:rPr>
-              <a:t>[</a:t>
-            </a:r>
-            <a:r>
-              <a:rPr sz="2200" spc="-25" dirty="0">
-                <a:latin typeface="Calibri"/>
-                <a:cs typeface="Calibri"/>
-              </a:rPr>
-              <a:t>1]</a:t>
-            </a:r>
             <a:endParaRPr sz="2200" dirty="0">
               <a:latin typeface="Calibri"/>
               <a:cs typeface="Calibri"/>
@@ -5682,21 +6159,14 @@
                 <a:latin typeface="Calibri"/>
                 <a:cs typeface="Calibri"/>
               </a:rPr>
-              <a:t>Прикладной фактор: Необходимость адаптации SOTA-моделей (YOLO) к узкоспециализированным задачам.</a:t>
-            </a:r>
-            <a:r>
-              <a:rPr sz="2200" spc="-25" dirty="0" smtClean="0">
-                <a:latin typeface="Calibri"/>
-                <a:cs typeface="Calibri"/>
-              </a:rPr>
-              <a:t>[</a:t>
-            </a:r>
-            <a:r>
-              <a:rPr sz="2200" spc="-25" dirty="0">
-                <a:latin typeface="Calibri"/>
-                <a:cs typeface="Calibri"/>
-              </a:rPr>
-              <a:t>2]</a:t>
+              <a:t>Прикладной фактор: Необходимость адаптации SOTA-моделей (YOLO) к узкоспециализированным задачам</a:t>
+            </a:r>
+            <a:r>
+              <a:rPr lang="ru-RU" sz="2200" dirty="0">
+                <a:latin typeface="Calibri"/>
+                <a:cs typeface="Calibri"/>
+              </a:rPr>
+              <a:t>.</a:t>
             </a:r>
             <a:endParaRPr sz="2200" dirty="0">
               <a:latin typeface="Calibri"/>
@@ -5723,20 +6193,6 @@
                 <a:cs typeface="Calibri"/>
               </a:rPr>
               <a:t>Инженерный фактор: Внедрение сложных ИИ-алгоритмов невозможно без создания интуитивного и автономного GUI.</a:t>
-            </a:r>
-            <a:r>
-              <a:rPr sz="2200" spc="-25" dirty="0" smtClean="0">
-                <a:latin typeface="Calibri"/>
-                <a:cs typeface="Calibri"/>
-              </a:rPr>
-              <a:t>[</a:t>
-            </a:r>
-            <a:r>
-              <a:rPr sz="2200" spc="-25" dirty="0">
-                <a:latin typeface="Calibri"/>
-                <a:cs typeface="Calibri"/>
-              </a:rPr>
-              <a:t>3]</a:t>
             </a:r>
             <a:endParaRPr sz="2200" dirty="0">
               <a:latin typeface="Calibri"/>
@@ -7663,34 +8119,6 @@
           </a:p>
         </p:txBody>
       </p:sp>
-      <p:pic>
-        <p:nvPicPr>
-          <p:cNvPr id="3" name="object 3"/>
-          <p:cNvPicPr/>
-          <p:nvPr/>
-        </p:nvPicPr>
-        <p:blipFill>
-          <a:blip r:embed="rId2">
-            <a:extLst>
-              <a:ext uri="{28A0092B-C50C-407E-A947-70E740481C1C}">
-                <a14:useLocalDpi xmlns:a14="http://schemas.microsoft.com/office/drawing/2010/main" val="0"/>
-              </a:ext>
-            </a:extLst>
-          </a:blip>
-          <a:stretch>
-            <a:fillRect/>
-          </a:stretch>
-        </p:blipFill>
-        <p:spPr>
-          <a:xfrm>
-            <a:off x="3429000" y="1259027"/>
-            <a:ext cx="4953000" cy="5439918"/>
-          </a:xfrm>
-          <a:prstGeom prst="rect">
-            <a:avLst/>
-          </a:prstGeom>
-        </p:spPr>
-      </p:pic>
       <p:sp>
         <p:nvSpPr>
           <p:cNvPr id="5" name="object 4"/>
@@ -7747,6 +8175,36 @@
           </a:p>
         </p:txBody>
       </p:sp>
+      <p:pic>
+        <p:nvPicPr>
+          <p:cNvPr id="4" name="Рисунок 3"/>
+          <p:cNvPicPr>
+            <a:picLocks noChangeAspect="1"/>
+          </p:cNvPicPr>
+          <p:nvPr/>
+        </p:nvPicPr>
+        <p:blipFill>
+          <a:blip r:embed="rId2">
+            <a:extLst>
+              <a:ext uri="{28A0092B-C50C-407E-A947-70E740481C1C}">
+                <a14:useLocalDpi xmlns:a14="http://schemas.microsoft.com/office/drawing/2010/main" val="0"/>
+              </a:ext>
+            </a:extLst>
+          </a:blip>
+          <a:stretch>
+            <a:fillRect/>
+          </a:stretch>
+        </p:blipFill>
+        <p:spPr>
+          <a:xfrm>
+            <a:off x="2880376" y="1259027"/>
+            <a:ext cx="6431245" cy="5041957"/>
+          </a:xfrm>
+          <a:prstGeom prst="rect">
+            <a:avLst/>
+          </a:prstGeom>
+        </p:spPr>
+      </p:pic>
     </p:spTree>
   </p:cSld>
   <p:clrMapOvr>
@@ -7847,8 +8305,8 @@
         </p:blipFill>
         <p:spPr>
           <a:xfrm>
-            <a:off x="2362200" y="678687"/>
-            <a:ext cx="7295898" cy="5874513"/>
+            <a:off x="2576100" y="678687"/>
+            <a:ext cx="6868097" cy="5874513"/>
           </a:xfrm>
           <a:prstGeom prst="rect">
             <a:avLst/>
@@ -8155,8 +8613,8 @@
         </p:nvSpPr>
         <p:spPr>
           <a:xfrm>
-            <a:off x="1371600" y="1086511"/>
-            <a:ext cx="10210801" cy="5612434"/>
+            <a:off x="842645" y="1259027"/>
+            <a:ext cx="10972800" cy="4596771"/>
           </a:xfrm>
           <a:prstGeom prst="rect">
             <a:avLst/>
@@ -8168,20 +8626,39 @@
           </a:bodyPr>
           <a:lstStyle/>
           <a:p>
-            <a:pPr marL="241300" indent="-228600">
+            <a:pPr marL="12700">
               <a:lnSpc>
                 <a:spcPct val="150000"/>
               </a:lnSpc>
               <a:spcBef>
                 <a:spcPts val="105"/>
               </a:spcBef>
-              <a:buFont typeface="Arial MT"/>
-              <a:buChar char="•"/>
               <a:tabLst>
                 <a:tab pos="241300" algn="l"/>
               </a:tabLst>
             </a:pPr>
             <a:r>
+              <a:rPr lang="ru-RU" sz="2200" dirty="0" smtClean="0">
+                <a:latin typeface="Calibri"/>
+                <a:cs typeface="Calibri"/>
+              </a:rPr>
+              <a:t>Среда разработки</a:t>
+            </a:r>
+            <a:r>
+              <a:rPr lang="en-US" sz="2200" dirty="0" smtClean="0">
+                <a:latin typeface="Calibri"/>
+                <a:cs typeface="Calibri"/>
+              </a:rPr>
+              <a:t> </a:t>
+            </a:r>
+            <a:r>
+              <a:rPr lang="ru-RU" sz="2200" dirty="0" smtClean="0">
+                <a:latin typeface="Calibri"/>
+                <a:cs typeface="Calibri"/>
+              </a:rPr>
+              <a:t>- </a:t>
+            </a:r>
+            <a:r>
               <a:rPr lang="en-US" sz="2200" dirty="0" err="1" smtClean="0">
                 <a:latin typeface="Calibri"/>
                 <a:cs typeface="Calibri"/>
@@ -8203,51 +8680,99 @@
               <a:t>PyCharm</a:t>
             </a:r>
             <a:r>
+              <a:rPr lang="ru-RU" sz="2200" dirty="0">
+                <a:latin typeface="Calibri"/>
+                <a:cs typeface="Calibri"/>
+              </a:rPr>
+              <a:t/>
+            </a:r>
+            <a:br>
+              <a:rPr lang="ru-RU" sz="2200" dirty="0">
+                <a:latin typeface="Calibri"/>
+                <a:cs typeface="Calibri"/>
+              </a:rPr>
+            </a:br>
+            <a:r>
+              <a:rPr lang="ru-RU" sz="2200" dirty="0" smtClean="0">
+                <a:latin typeface="Calibri"/>
+                <a:cs typeface="Calibri"/>
+              </a:rPr>
+              <a:t>Язык программирования - </a:t>
+            </a:r>
+            <a:r>
               <a:rPr lang="en-US" sz="2200" dirty="0" smtClean="0">
                 <a:latin typeface="Calibri"/>
                 <a:cs typeface="Calibri"/>
               </a:rPr>
-              <a:t> – </a:t>
-            </a:r>
-            <a:r>
-              <a:rPr lang="ru-RU" sz="2200" dirty="0" smtClean="0">
-                <a:latin typeface="Calibri"/>
-                <a:cs typeface="Calibri"/>
-              </a:rPr>
-              <a:t>среда разработки</a:t>
-            </a:r>
-            <a:endParaRPr lang="en-US" sz="2200" dirty="0" smtClean="0">
+              <a:t>Python v3.12.5 </a:t>
+            </a:r>
+            <a:endParaRPr lang="ru-RU" sz="2200" dirty="0" smtClean="0">
               <a:latin typeface="Calibri"/>
               <a:cs typeface="Calibri"/>
             </a:endParaRPr>
           </a:p>
           <a:p>
-            <a:pPr marL="241300" indent="-228600">
+            <a:pPr marL="12700">
               <a:lnSpc>
                 <a:spcPct val="150000"/>
               </a:lnSpc>
               <a:spcBef>
                 <a:spcPts val="105"/>
               </a:spcBef>
-              <a:buFont typeface="Arial MT"/>
+              <a:tabLst>
+                <a:tab pos="241300" algn="l"/>
+              </a:tabLst>
+            </a:pPr>
+            <a:r>
+              <a:rPr lang="ru-RU" sz="2200" dirty="0" smtClean="0">
+                <a:latin typeface="Calibri"/>
+                <a:cs typeface="Calibri"/>
+              </a:rPr>
+              <a:t>Библиотеки используемые в проекте:</a:t>
+            </a:r>
+            <a:endParaRPr lang="en-US" sz="2200" dirty="0" smtClean="0">
+              <a:latin typeface="Calibri"/>
+              <a:cs typeface="Calibri"/>
+            </a:endParaRPr>
+          </a:p>
+          <a:p>
+            <a:pPr marL="355600" indent="-342900">
+              <a:lnSpc>
+                <a:spcPct val="150000"/>
+              </a:lnSpc>
+              <a:buFont typeface="Arial" panose="020B0604020202020204" pitchFamily="34" charset="0"/>
               <a:buChar char="•"/>
               <a:tabLst>
                 <a:tab pos="241300" algn="l"/>
               </a:tabLst>
             </a:pPr>
             <a:r>
+              <a:rPr lang="ru-RU" sz="2200" dirty="0" smtClean="0">
+                <a:latin typeface="Calibri"/>
+                <a:cs typeface="Calibri"/>
+              </a:rPr>
+              <a:t>Построения </a:t>
+            </a:r>
+            <a:r>
               <a:rPr lang="en-US" sz="2200" dirty="0" smtClean="0">
                 <a:latin typeface="Calibri"/>
                 <a:cs typeface="Calibri"/>
               </a:rPr>
-              <a:t>Python v3.12.5 – </a:t>
+              <a:t>GUI</a:t>
             </a:r>
             <a:r>
               <a:rPr lang="ru-RU" sz="2200" dirty="0" smtClean="0">
                 <a:latin typeface="Calibri"/>
                 <a:cs typeface="Calibri"/>
               </a:rPr>
-              <a:t>язык программирования </a:t>
+              <a:t>: PyQt6</a:t>
+            </a:r>
+            <a:r>
+              <a:rPr lang="en-US" sz="2200" dirty="0" smtClean="0">
+                <a:latin typeface="Calibri"/>
+                <a:cs typeface="Calibri"/>
+              </a:rPr>
+              <a:t> v6.7.1; </a:t>
             </a:r>
             <a:endParaRPr lang="ru-RU" sz="2200" dirty="0" smtClean="0">
               <a:latin typeface="Calibri"/>
@@ -8255,436 +8780,293 @@
             </a:endParaRPr>
           </a:p>
           <a:p>
-            <a:pPr marL="241300" indent="-228600">
+            <a:pPr marL="355600" indent="-342900">
               <a:lnSpc>
                 <a:spcPct val="150000"/>
               </a:lnSpc>
-              <a:buFont typeface="Arial MT"/>
+              <a:buFont typeface="Arial" panose="020B0604020202020204" pitchFamily="34" charset="0"/>
               <a:buChar char="•"/>
               <a:tabLst>
                 <a:tab pos="241300" algn="l"/>
               </a:tabLst>
             </a:pPr>
             <a:r>
+              <a:rPr lang="ru-RU" sz="2200" spc="-10" dirty="0" smtClean="0">
+                <a:latin typeface="Calibri"/>
+                <a:cs typeface="Calibri"/>
+              </a:rPr>
+              <a:t>Детекция и идентификация объектов: </a:t>
+            </a:r>
+            <a:r>
+              <a:rPr lang="en-US" sz="2200" spc="-10" dirty="0" err="1" smtClean="0">
+                <a:latin typeface="Calibri"/>
+                <a:cs typeface="Calibri"/>
+              </a:rPr>
+              <a:t>ultralytics</a:t>
+            </a:r>
+            <a:r>
+              <a:rPr lang="ru-RU" sz="2200" spc="-10" dirty="0" smtClean="0">
+                <a:latin typeface="Calibri"/>
+                <a:cs typeface="Calibri"/>
+              </a:rPr>
+              <a:t> </a:t>
+            </a:r>
+            <a:r>
+              <a:rPr lang="en-US" sz="2200" spc="-10" dirty="0" smtClean="0">
+                <a:latin typeface="Calibri"/>
+                <a:cs typeface="Calibri"/>
+              </a:rPr>
+              <a:t>v8.3.40 , </a:t>
+            </a:r>
+            <a:r>
+              <a:rPr lang="ru-RU" sz="2200" dirty="0" err="1" smtClean="0">
+                <a:latin typeface="Calibri"/>
+                <a:cs typeface="Calibri"/>
+              </a:rPr>
+              <a:t>EasyOCR</a:t>
+            </a:r>
+            <a:r>
+              <a:rPr lang="en-US" sz="2200" dirty="0" smtClean="0">
+                <a:latin typeface="Calibri"/>
+                <a:cs typeface="Calibri"/>
+              </a:rPr>
+              <a:t> v1.7.2;</a:t>
+            </a:r>
+            <a:r>
               <a:rPr lang="ru-RU" sz="2200" dirty="0" smtClean="0">
                 <a:latin typeface="Calibri"/>
                 <a:cs typeface="Calibri"/>
               </a:rPr>
-              <a:t>PyQt6</a:t>
-            </a:r>
-            <a:r>
-              <a:rPr lang="en-US" sz="2200" dirty="0" smtClean="0">
-                <a:latin typeface="Calibri"/>
-                <a:cs typeface="Calibri"/>
-              </a:rPr>
               <a:t> </a:t>
             </a:r>
-            <a:r>
-              <a:rPr lang="en-US" sz="2200" dirty="0">
-                <a:latin typeface="Calibri"/>
-                <a:cs typeface="Calibri"/>
-              </a:rPr>
-              <a:t>v</a:t>
-            </a:r>
-            <a:r>
-              <a:rPr lang="en-US" sz="2200" dirty="0" smtClean="0">
-                <a:latin typeface="Calibri"/>
-                <a:cs typeface="Calibri"/>
-              </a:rPr>
-              <a:t>6.7.1</a:t>
-            </a:r>
-            <a:r>
-              <a:rPr lang="ru-RU" sz="2200" dirty="0" smtClean="0">
-                <a:latin typeface="Calibri"/>
-                <a:cs typeface="Calibri"/>
-              </a:rPr>
-              <a:t> – библиотека для построения </a:t>
-            </a:r>
-            <a:r>
-              <a:rPr lang="en-US" sz="2200" dirty="0" smtClean="0">
-                <a:latin typeface="Calibri"/>
-                <a:cs typeface="Calibri"/>
-              </a:rPr>
-              <a:t>GUI</a:t>
-            </a:r>
-            <a:endParaRPr lang="ru-RU" sz="2200" dirty="0" smtClean="0">
-              <a:latin typeface="Calibri"/>
-              <a:cs typeface="Calibri"/>
-            </a:endParaRPr>
-          </a:p>
-          <a:p>
-            <a:pPr marL="241300" indent="-228600">
+          </a:p>
+          <a:p>
+            <a:pPr marL="355600" indent="-342900">
               <a:lnSpc>
                 <a:spcPct val="150000"/>
               </a:lnSpc>
-              <a:buFont typeface="Arial MT"/>
+              <a:buFont typeface="Arial" panose="020B0604020202020204" pitchFamily="34" charset="0"/>
               <a:buChar char="•"/>
               <a:tabLst>
                 <a:tab pos="241300" algn="l"/>
               </a:tabLst>
             </a:pPr>
             <a:r>
-              <a:rPr lang="en-US" sz="2200" spc="-10" dirty="0" err="1">
-                <a:latin typeface="Calibri"/>
-                <a:cs typeface="Calibri"/>
-              </a:rPr>
-              <a:t>u</a:t>
-            </a:r>
-            <a:r>
-              <a:rPr lang="en-US" sz="2200" spc="-10" dirty="0" err="1" smtClean="0">
-                <a:latin typeface="Calibri"/>
-                <a:cs typeface="Calibri"/>
-              </a:rPr>
-              <a:t>ltralytics</a:t>
-            </a:r>
-            <a:r>
-              <a:rPr lang="ru-RU" sz="2200" spc="-10" dirty="0" smtClean="0">
-                <a:latin typeface="Calibri"/>
-                <a:cs typeface="Calibri"/>
-              </a:rPr>
-              <a:t> </a:t>
-            </a:r>
-            <a:r>
-              <a:rPr lang="en-US" sz="2200" spc="-10" dirty="0" smtClean="0">
-                <a:latin typeface="Calibri"/>
-                <a:cs typeface="Calibri"/>
-              </a:rPr>
-              <a:t>v8.3.40</a:t>
-            </a:r>
-            <a:r>
-              <a:rPr lang="ru-RU" sz="2200" spc="-10" dirty="0" smtClean="0">
-                <a:latin typeface="Calibri"/>
-                <a:cs typeface="Calibri"/>
-              </a:rPr>
-              <a:t> –</a:t>
-            </a:r>
-            <a:r>
-              <a:rPr lang="en-US" sz="2200" spc="-10" dirty="0" smtClean="0">
-                <a:latin typeface="Calibri"/>
-                <a:cs typeface="Calibri"/>
-              </a:rPr>
-              <a:t> </a:t>
-            </a:r>
-            <a:r>
-              <a:rPr lang="ru-RU" sz="2200" spc="-10" dirty="0" smtClean="0">
-                <a:latin typeface="Calibri"/>
-                <a:cs typeface="Calibri"/>
-              </a:rPr>
-              <a:t>библиотека для работы нейросети </a:t>
-            </a:r>
-            <a:r>
-              <a:rPr lang="en-US" sz="2200" spc="-10" dirty="0" smtClean="0">
-                <a:latin typeface="Calibri"/>
-                <a:cs typeface="Calibri"/>
-              </a:rPr>
-              <a:t>YOLOv11</a:t>
-            </a:r>
-            <a:endParaRPr lang="ru-RU" sz="2200" spc="-10" dirty="0" smtClean="0">
+              <a:rPr lang="ru-RU" sz="2200" dirty="0" smtClean="0">
+                <a:latin typeface="Calibri"/>
+                <a:cs typeface="Calibri"/>
+              </a:rPr>
+              <a:t>Работа с изображениями: </a:t>
+            </a:r>
+            <a:r>
+              <a:rPr lang="en-US" sz="2200" dirty="0" err="1" smtClean="0">
+                <a:latin typeface="Calibri"/>
+                <a:cs typeface="Calibri"/>
+              </a:rPr>
+              <a:t>opencv</a:t>
+            </a:r>
+            <a:r>
+              <a:rPr lang="en-US" sz="2200" dirty="0" smtClean="0">
+                <a:latin typeface="Calibri"/>
+                <a:cs typeface="Calibri"/>
+              </a:rPr>
+              <a:t> v4.10.0.84 , Pillow v10.4.0</a:t>
+            </a:r>
+            <a:r>
+              <a:rPr lang="en-US" sz="2200" dirty="0">
+                <a:latin typeface="Calibri"/>
+                <a:cs typeface="Calibri"/>
+              </a:rPr>
+              <a:t>;</a:t>
+            </a:r>
+            <a:endParaRPr lang="ru-RU" sz="2200" dirty="0" smtClean="0">
               <a:latin typeface="Calibri"/>
               <a:cs typeface="Calibri"/>
             </a:endParaRPr>
           </a:p>
           <a:p>
-            <a:pPr marL="241300" indent="-228600">
+            <a:pPr marL="355600" indent="-342900">
               <a:lnSpc>
                 <a:spcPct val="150000"/>
               </a:lnSpc>
-              <a:buFont typeface="Arial MT"/>
+              <a:buFont typeface="Arial" panose="020B0604020202020204" pitchFamily="34" charset="0"/>
               <a:buChar char="•"/>
               <a:tabLst>
                 <a:tab pos="241300" algn="l"/>
               </a:tabLst>
             </a:pPr>
             <a:r>
-              <a:rPr lang="ru-RU" sz="2200" dirty="0" err="1" smtClean="0">
-                <a:latin typeface="Calibri"/>
-                <a:cs typeface="Calibri"/>
-              </a:rPr>
-              <a:t>EasyOCR</a:t>
+              <a:rPr lang="ru-RU" sz="2200" dirty="0" smtClean="0">
+                <a:latin typeface="Calibri"/>
+                <a:cs typeface="Calibri"/>
+              </a:rPr>
+              <a:t>Экспорт </a:t>
             </a:r>
             <a:r>
               <a:rPr lang="en-US" sz="2200" dirty="0" smtClean="0">
                 <a:latin typeface="Calibri"/>
                 <a:cs typeface="Calibri"/>
               </a:rPr>
-              <a:t> </a:t>
-            </a:r>
-            <a:r>
-              <a:rPr lang="en-US" sz="2200" dirty="0">
-                <a:latin typeface="Calibri"/>
-                <a:cs typeface="Calibri"/>
-              </a:rPr>
-              <a:t>v1.7.2</a:t>
+              <a:t>PDF </a:t>
             </a:r>
             <a:r>
               <a:rPr lang="ru-RU" sz="2200" dirty="0" smtClean="0">
                 <a:latin typeface="Calibri"/>
                 <a:cs typeface="Calibri"/>
               </a:rPr>
-              <a:t> – библиотека для автономного распознавания символов</a:t>
-            </a:r>
-            <a:endParaRPr lang="en-US" sz="2200" dirty="0" smtClean="0">
+              <a:t>и </a:t>
+            </a:r>
+            <a:r>
+              <a:rPr lang="en-US" sz="2200" dirty="0" smtClean="0">
+                <a:latin typeface="Calibri"/>
+                <a:cs typeface="Calibri"/>
+              </a:rPr>
+              <a:t>EXCEL: </a:t>
+            </a:r>
+            <a:r>
+              <a:rPr lang="en-US" sz="2200" dirty="0" err="1" smtClean="0">
+                <a:latin typeface="Calibri"/>
+                <a:cs typeface="Calibri"/>
+              </a:rPr>
+              <a:t>reportlab</a:t>
+            </a:r>
+            <a:r>
+              <a:rPr lang="en-US" sz="2200" dirty="0" smtClean="0">
+                <a:latin typeface="Calibri"/>
+                <a:cs typeface="Calibri"/>
+              </a:rPr>
+              <a:t> v4.2.5 , </a:t>
+            </a:r>
+            <a:r>
+              <a:rPr lang="en-US" sz="2200" dirty="0" err="1" smtClean="0">
+                <a:latin typeface="Calibri"/>
+                <a:cs typeface="Calibri"/>
+              </a:rPr>
+              <a:t>openpyxl</a:t>
+            </a:r>
+            <a:r>
+              <a:rPr lang="en-US" sz="2200" dirty="0" smtClean="0">
+                <a:latin typeface="Calibri"/>
+                <a:cs typeface="Calibri"/>
+              </a:rPr>
+              <a:t> v3.1.5;</a:t>
+            </a:r>
+            <a:endParaRPr lang="ru-RU" sz="2200" dirty="0" smtClean="0">
               <a:latin typeface="Calibri"/>
               <a:cs typeface="Calibri"/>
             </a:endParaRPr>
           </a:p>
           <a:p>
-            <a:pPr marL="241300" indent="-228600">
+            <a:pPr marL="355600" indent="-342900">
               <a:lnSpc>
                 <a:spcPct val="150000"/>
               </a:lnSpc>
-              <a:buFont typeface="Arial MT"/>
+              <a:buFont typeface="Arial" panose="020B0604020202020204" pitchFamily="34" charset="0"/>
               <a:buChar char="•"/>
               <a:tabLst>
                 <a:tab pos="241300" algn="l"/>
               </a:tabLst>
             </a:pPr>
             <a:r>
+              <a:rPr lang="ru-RU" sz="2200" dirty="0" smtClean="0">
+                <a:latin typeface="Calibri"/>
+                <a:cs typeface="Calibri"/>
+              </a:rPr>
+              <a:t>Обработка массивов и генерация графиков: pandas v2.2.3</a:t>
+            </a:r>
+            <a:r>
+              <a:rPr lang="en-US" sz="2200" dirty="0">
+                <a:latin typeface="Calibri"/>
+                <a:cs typeface="Calibri"/>
+              </a:rPr>
+              <a:t> </a:t>
+            </a:r>
+            <a:r>
+              <a:rPr lang="en-US" sz="2200" dirty="0" smtClean="0">
+                <a:latin typeface="Calibri"/>
+                <a:cs typeface="Calibri"/>
+              </a:rPr>
+              <a:t>,</a:t>
+            </a:r>
+            <a:r>
+              <a:rPr lang="ru-RU" sz="2200" dirty="0" smtClean="0">
+                <a:latin typeface="Calibri"/>
+                <a:cs typeface="Calibri"/>
+              </a:rPr>
+              <a:t> </a:t>
+            </a:r>
+            <a:r>
               <a:rPr lang="en-US" sz="2200" dirty="0" err="1" smtClean="0">
                 <a:latin typeface="Calibri"/>
                 <a:cs typeface="Calibri"/>
               </a:rPr>
-              <a:t>opencv</a:t>
+              <a:t>matplotlib</a:t>
+            </a:r>
+            <a:r>
+              <a:rPr lang="ru-RU" sz="2200" dirty="0" smtClean="0">
+                <a:latin typeface="Calibri"/>
+                <a:cs typeface="Calibri"/>
+              </a:rPr>
+              <a:t> </a:t>
             </a:r>
             <a:r>
               <a:rPr lang="en-US" sz="2200" dirty="0" smtClean="0">
                 <a:latin typeface="Calibri"/>
                 <a:cs typeface="Calibri"/>
               </a:rPr>
-              <a:t> v4.10.0.84 – </a:t>
-            </a:r>
-            <a:r>
-              <a:rPr lang="ru-RU" sz="2200" dirty="0" smtClean="0">
-                <a:latin typeface="Calibri"/>
-                <a:cs typeface="Calibri"/>
-              </a:rPr>
-              <a:t>библиотека для предобработки изображений</a:t>
-            </a:r>
-          </a:p>
-          <a:p>
-            <a:pPr marL="241300" indent="-228600">
+              <a:t>v3.9.2; </a:t>
+            </a:r>
+          </a:p>
+          <a:p>
+            <a:pPr marL="355600" indent="-342900">
               <a:lnSpc>
                 <a:spcPct val="150000"/>
               </a:lnSpc>
-              <a:buFont typeface="Arial MT"/>
+              <a:buFont typeface="Arial" panose="020B0604020202020204" pitchFamily="34" charset="0"/>
               <a:buChar char="•"/>
               <a:tabLst>
                 <a:tab pos="241300" algn="l"/>
               </a:tabLst>
             </a:pPr>
             <a:r>
-              <a:rPr lang="en-US" sz="2200" dirty="0" smtClean="0">
-                <a:latin typeface="Calibri"/>
-                <a:cs typeface="Calibri"/>
-              </a:rPr>
-              <a:t>Pillow v10.4.0 –</a:t>
-            </a:r>
-            <a:r>
-              <a:rPr lang="ru-RU" sz="2200" dirty="0">
+              <a:rPr lang="ru-RU" sz="2200" dirty="0" smtClean="0">
+                <a:latin typeface="Calibri"/>
+                <a:cs typeface="Calibri"/>
+              </a:rPr>
+              <a:t>СУБД</a:t>
+            </a:r>
+            <a:r>
+              <a:rPr lang="en-US" sz="2200" dirty="0">
+                <a:latin typeface="Calibri"/>
+                <a:cs typeface="Calibri"/>
+              </a:rPr>
+              <a:t>:</a:t>
+            </a:r>
+            <a:r>
+              <a:rPr lang="ru-RU" sz="2200" dirty="0" smtClean="0">
                 <a:latin typeface="Calibri"/>
                 <a:cs typeface="Calibri"/>
               </a:rPr>
               <a:t> </a:t>
             </a:r>
             <a:r>
-              <a:rPr lang="ru-RU" sz="2200" dirty="0" smtClean="0">
-                <a:latin typeface="Calibri"/>
-                <a:cs typeface="Calibri"/>
-              </a:rPr>
-              <a:t>библиотека для</a:t>
-            </a:r>
-            <a:r>
-              <a:rPr lang="en-US" sz="2200" dirty="0" smtClean="0">
-                <a:latin typeface="Calibri"/>
-                <a:cs typeface="Calibri"/>
-              </a:rPr>
-              <a:t> </a:t>
-            </a:r>
-            <a:r>
-              <a:rPr lang="ru-RU" sz="2200" dirty="0" smtClean="0">
-                <a:latin typeface="Calibri"/>
-                <a:cs typeface="Calibri"/>
-              </a:rPr>
-              <a:t>кадрирования</a:t>
-            </a:r>
-            <a:r>
-              <a:rPr lang="ru-RU" sz="2200" dirty="0" smtClean="0">
-                <a:latin typeface="Calibri"/>
-                <a:cs typeface="Calibri"/>
-              </a:rPr>
-              <a:t> изображениями</a:t>
-            </a:r>
-          </a:p>
-          <a:p>
-            <a:pPr marL="241300" indent="-228600">
-              <a:lnSpc>
-                <a:spcPct val="150000"/>
-              </a:lnSpc>
-              <a:buFont typeface="Arial MT"/>
-              <a:buChar char="•"/>
-              <a:tabLst>
-                <a:tab pos="241300" algn="l"/>
-              </a:tabLst>
-            </a:pPr>
-            <a:r>
               <a:rPr lang="ru-RU" sz="2200" dirty="0" err="1" smtClean="0">
                 <a:latin typeface="Calibri"/>
                 <a:cs typeface="Calibri"/>
               </a:rPr>
-              <a:t>pandas</a:t>
-            </a:r>
-            <a:r>
-              <a:rPr lang="ru-RU" sz="2200" dirty="0" smtClean="0">
-                <a:latin typeface="Calibri"/>
-                <a:cs typeface="Calibri"/>
-              </a:rPr>
-              <a:t> v2.2.3 </a:t>
-            </a:r>
-            <a:r>
-              <a:rPr lang="en-US" sz="2200" dirty="0" smtClean="0">
-                <a:latin typeface="Calibri"/>
-                <a:cs typeface="Calibri"/>
-              </a:rPr>
-              <a:t>–</a:t>
-            </a:r>
-            <a:r>
-              <a:rPr lang="ru-RU" sz="2200" dirty="0" smtClean="0">
-                <a:latin typeface="Calibri"/>
-                <a:cs typeface="Calibri"/>
-              </a:rPr>
-              <a:t> библиотека для работы с массивами</a:t>
-            </a:r>
-          </a:p>
-          <a:p>
-            <a:pPr marL="241300" indent="-228600">
-              <a:lnSpc>
-                <a:spcPct val="150000"/>
-              </a:lnSpc>
-              <a:buFont typeface="Arial MT"/>
-              <a:buChar char="•"/>
-              <a:tabLst>
-                <a:tab pos="241300" algn="l"/>
-              </a:tabLst>
-            </a:pPr>
-            <a:r>
-              <a:rPr lang="en-US" sz="2200" dirty="0" err="1" smtClean="0">
-                <a:latin typeface="Calibri"/>
-                <a:cs typeface="Calibri"/>
-              </a:rPr>
-              <a:t>matplotlib</a:t>
-            </a:r>
-            <a:r>
-              <a:rPr lang="ru-RU" sz="2200" dirty="0" smtClean="0">
-                <a:latin typeface="Calibri"/>
-                <a:cs typeface="Calibri"/>
-              </a:rPr>
-              <a:t> </a:t>
-            </a:r>
-            <a:r>
-              <a:rPr lang="en-US" sz="2200" dirty="0" smtClean="0">
-                <a:latin typeface="Calibri"/>
-                <a:cs typeface="Calibri"/>
-              </a:rPr>
-              <a:t>v3.9.2 – </a:t>
-            </a:r>
-            <a:r>
-              <a:rPr lang="ru-RU" sz="2200" dirty="0" smtClean="0">
-                <a:latin typeface="Calibri"/>
-                <a:cs typeface="Calibri"/>
-              </a:rPr>
-              <a:t>библиотека для генерация графиков</a:t>
-            </a:r>
-          </a:p>
-          <a:p>
-            <a:pPr marL="241300" indent="-228600">
-              <a:lnSpc>
-                <a:spcPct val="150000"/>
-              </a:lnSpc>
-              <a:buFont typeface="Arial MT"/>
-              <a:buChar char="•"/>
-              <a:tabLst>
-                <a:tab pos="241300" algn="l"/>
-              </a:tabLst>
-            </a:pPr>
-            <a:r>
-              <a:rPr lang="en-US" sz="2200" dirty="0" err="1" smtClean="0">
-                <a:latin typeface="Calibri"/>
-                <a:cs typeface="Calibri"/>
-              </a:rPr>
-              <a:t>reportlab</a:t>
-            </a:r>
-            <a:r>
-              <a:rPr lang="en-US" sz="2200" dirty="0" smtClean="0">
-                <a:latin typeface="Calibri"/>
-                <a:cs typeface="Calibri"/>
-              </a:rPr>
-              <a:t> v4.2.5;openpyxl v3.1.5– </a:t>
-            </a:r>
-            <a:r>
-              <a:rPr lang="ru-RU" sz="2200" dirty="0" smtClean="0">
-                <a:latin typeface="Calibri"/>
-                <a:cs typeface="Calibri"/>
-              </a:rPr>
-              <a:t>библиотеки для экспорта </a:t>
-            </a:r>
-            <a:r>
-              <a:rPr lang="en-US" sz="2200" dirty="0" smtClean="0">
-                <a:latin typeface="Calibri"/>
-                <a:cs typeface="Calibri"/>
-              </a:rPr>
-              <a:t>pdf </a:t>
-            </a:r>
-            <a:r>
-              <a:rPr lang="ru-RU" sz="2200" dirty="0" smtClean="0">
-                <a:latin typeface="Calibri"/>
-                <a:cs typeface="Calibri"/>
-              </a:rPr>
-              <a:t>и </a:t>
-            </a:r>
-            <a:r>
-              <a:rPr lang="en-US" sz="2200" dirty="0" err="1" smtClean="0">
-                <a:latin typeface="Calibri"/>
-                <a:cs typeface="Calibri"/>
-              </a:rPr>
-              <a:t>exel</a:t>
-            </a:r>
-            <a:r>
-              <a:rPr lang="en-US" sz="2200" dirty="0" smtClean="0">
-                <a:latin typeface="Calibri"/>
-                <a:cs typeface="Calibri"/>
-              </a:rPr>
-              <a:t> </a:t>
+              <a:t>SQLite</a:t>
+            </a:r>
+            <a:r>
+              <a:rPr lang="en-US" sz="2200" dirty="0">
+                <a:latin typeface="Calibri"/>
+                <a:cs typeface="Calibri"/>
+              </a:rPr>
+              <a:t>.</a:t>
             </a:r>
             <a:endParaRPr lang="ru-RU" sz="2200" dirty="0" smtClean="0">
               <a:latin typeface="Calibri"/>
               <a:cs typeface="Calibri"/>
             </a:endParaRPr>
-          </a:p>
-          <a:p>
-            <a:pPr marL="241300" indent="-228600">
-              <a:lnSpc>
-                <a:spcPct val="150000"/>
-              </a:lnSpc>
-              <a:buFont typeface="Arial MT"/>
-              <a:buChar char="•"/>
-              <a:tabLst>
-                <a:tab pos="241300" algn="l"/>
-              </a:tabLst>
-            </a:pPr>
-            <a:r>
-              <a:rPr lang="ru-RU" sz="2200" dirty="0" err="1" smtClean="0">
-                <a:latin typeface="Calibri"/>
-                <a:cs typeface="Calibri"/>
-              </a:rPr>
-              <a:t>SQLite</a:t>
-            </a:r>
-            <a:r>
-              <a:rPr lang="ru-RU" sz="2200" dirty="0" smtClean="0">
-                <a:latin typeface="Calibri"/>
-                <a:cs typeface="Calibri"/>
-              </a:rPr>
-              <a:t> – встраиваемая СУБД для надежного локального хранения данных</a:t>
-            </a:r>
           </a:p>
         </p:txBody>
       </p:sp>
@@ -8735,6 +9117,52 @@
               <a:t>/14</a:t>
             </a:r>
             <a:endParaRPr spc="-20" dirty="0">
+              <a:solidFill>
+                <a:srgbClr val="767676"/>
+              </a:solidFill>
+              <a:latin typeface="Calibri"/>
+              <a:cs typeface="Calibri"/>
+            </a:endParaRPr>
+          </a:p>
+        </p:txBody>
+      </p:sp>
+      <p:sp>
+        <p:nvSpPr>
+          <p:cNvPr id="5" name="Прямоугольник 4"/>
+          <p:cNvSpPr/>
+          <p:nvPr/>
+        </p:nvSpPr>
+        <p:spPr>
+          <a:xfrm>
+            <a:off x="831850" y="6378218"/>
+            <a:ext cx="4425950" cy="323165"/>
+          </a:xfrm>
+          <a:prstGeom prst="rect">
+            <a:avLst/>
+          </a:prstGeom>
+        </p:spPr>
+        <p:txBody>
+          <a:bodyPr wrap="square">
+            <a:spAutoFit/>
+          </a:bodyPr>
+          <a:lstStyle/>
+          <a:p>
+            <a:pPr marL="12700">
+              <a:lnSpc>
+                <a:spcPts val="1810"/>
+              </a:lnSpc>
+            </a:pPr>
+            <a:r>
+              <a:rPr lang="en-US" spc="-20" dirty="0">
+                <a:solidFill>
+                  <a:srgbClr val="767676"/>
+                </a:solidFill>
+                <a:latin typeface="Calibri"/>
+                <a:cs typeface="Calibri"/>
+              </a:rPr>
+              <a:t>https://github.com/GFooX9/CourseWork2026</a:t>
+            </a:r>
+            <a:endParaRPr lang="ru-RU" spc="-20" dirty="0">
               <a:solidFill>
                 <a:srgbClr val="767676"/>
               </a:solidFill>

</xml_diff>

<commit_message>
Add README_diagrams for diagrams components and some fix presentation
</commit_message>
<xml_diff>
--- a/Documentation/Official documents/PPTX/Презентация курсовой работы.pptx
+++ b/Documentation/Official documents/PPTX/Презентация курсовой работы.pptx
@@ -200,7 +200,7 @@
           <a:p>
             <a:fld id="{1D8BD707-D9CF-40AE-B4C6-C98DA3205C09}" type="datetimeFigureOut">
               <a:rPr lang="en-US"/>
-              <a:t>6/6/2026</a:t>
+              <a:t>6/7/2026</a:t>
             </a:fld>
             <a:endParaRPr lang="en-US"/>
           </a:p>
@@ -389,7 +389,7 @@
           <a:p>
             <a:fld id="{1D8BD707-D9CF-40AE-B4C6-C98DA3205C09}" type="datetimeFigureOut">
               <a:rPr lang="en-US"/>
-              <a:t>6/6/2026</a:t>
+              <a:t>6/7/2026</a:t>
             </a:fld>
             <a:endParaRPr lang="en-US"/>
           </a:p>
@@ -615,7 +615,7 @@
           <a:p>
             <a:fld id="{1D8BD707-D9CF-40AE-B4C6-C98DA3205C09}" type="datetimeFigureOut">
               <a:rPr lang="en-US"/>
-              <a:t>6/6/2026</a:t>
+              <a:t>6/7/2026</a:t>
             </a:fld>
             <a:endParaRPr lang="en-US"/>
           </a:p>
@@ -775,7 +775,7 @@
           <a:p>
             <a:fld id="{1D8BD707-D9CF-40AE-B4C6-C98DA3205C09}" type="datetimeFigureOut">
               <a:rPr lang="en-US"/>
-              <a:t>6/6/2026</a:t>
+              <a:t>6/7/2026</a:t>
             </a:fld>
             <a:endParaRPr lang="en-US"/>
           </a:p>
@@ -906,7 +906,7 @@
           <a:p>
             <a:fld id="{1D8BD707-D9CF-40AE-B4C6-C98DA3205C09}" type="datetimeFigureOut">
               <a:rPr lang="en-US"/>
-              <a:t>6/6/2026</a:t>
+              <a:t>6/7/2026</a:t>
             </a:fld>
             <a:endParaRPr lang="en-US"/>
           </a:p>
@@ -1143,7 +1143,7 @@
           <a:p>
             <a:fld id="{1D8BD707-D9CF-40AE-B4C6-C98DA3205C09}" type="datetimeFigureOut">
               <a:rPr lang="en-US"/>
-              <a:t>6/6/2026</a:t>
+              <a:t>6/7/2026</a:t>
             </a:fld>
             <a:endParaRPr lang="en-US"/>
           </a:p>
@@ -6336,14 +6336,14 @@
           <p:nvPr>
             <p:extLst>
               <p:ext uri="{D42A27DB-BD31-4B8C-83A1-F6EECF244321}">
-                <p14:modId xmlns:p14="http://schemas.microsoft.com/office/powerpoint/2010/main" val="1582852888"/>
+                <p14:modId xmlns:p14="http://schemas.microsoft.com/office/powerpoint/2010/main" val="1772950814"/>
               </p:ext>
             </p:extLst>
           </p:nvPr>
         </p:nvGraphicFramePr>
         <p:xfrm>
           <a:off x="311150" y="1112011"/>
-          <a:ext cx="11557000" cy="5078730"/>
+          <a:ext cx="11548110" cy="4260598"/>
         </p:xfrm>
         <a:graphic>
           <a:graphicData uri="http://schemas.openxmlformats.org/drawingml/2006/table">
@@ -6352,35 +6352,35 @@
                 <a:tableStyleId>{2D5ABB26-0587-4C30-8999-92F81FD0307C}</a:tableStyleId>
               </a:tblPr>
               <a:tblGrid>
-                <a:gridCol w="2311400">
+                <a:gridCol w="4260850">
                   <a:extLst>
                     <a:ext uri="{9D8B030D-6E8A-4147-A177-3AD203B41FA5}">
                       <a16:colId xmlns:a16="http://schemas.microsoft.com/office/drawing/2014/main" val="20000"/>
                     </a:ext>
                   </a:extLst>
                 </a:gridCol>
-                <a:gridCol w="2311400">
+                <a:gridCol w="1600200">
                   <a:extLst>
                     <a:ext uri="{9D8B030D-6E8A-4147-A177-3AD203B41FA5}">
                       <a16:colId xmlns:a16="http://schemas.microsoft.com/office/drawing/2014/main" val="20001"/>
                     </a:ext>
                   </a:extLst>
                 </a:gridCol>
-                <a:gridCol w="2311400">
+                <a:gridCol w="1905000">
                   <a:extLst>
                     <a:ext uri="{9D8B030D-6E8A-4147-A177-3AD203B41FA5}">
                       <a16:colId xmlns:a16="http://schemas.microsoft.com/office/drawing/2014/main" val="20002"/>
                     </a:ext>
                   </a:extLst>
                 </a:gridCol>
-                <a:gridCol w="2311400">
+                <a:gridCol w="1905000">
                   <a:extLst>
                     <a:ext uri="{9D8B030D-6E8A-4147-A177-3AD203B41FA5}">
                       <a16:colId xmlns:a16="http://schemas.microsoft.com/office/drawing/2014/main" val="20003"/>
                     </a:ext>
                   </a:extLst>
                 </a:gridCol>
-                <a:gridCol w="2311400">
+                <a:gridCol w="1877060">
                   <a:extLst>
                     <a:ext uri="{9D8B030D-6E8A-4147-A177-3AD203B41FA5}">
                       <a16:colId xmlns:a16="http://schemas.microsoft.com/office/drawing/2014/main" val="20004"/>
@@ -6403,13 +6403,13 @@
                         </a:spcBef>
                       </a:pPr>
                       <a:r>
-                        <a:rPr sz="2000" b="1" spc="-10" dirty="0">
+                        <a:rPr sz="2400" b="1" spc="-10" dirty="0">
                           <a:latin typeface="Calibri"/>
                           <a:cs typeface="Calibri"/>
                         </a:rPr>
                         <a:t>Критерий</a:t>
                       </a:r>
-                      <a:endParaRPr sz="2000" dirty="0">
+                      <a:endParaRPr sz="2400" dirty="0">
                         <a:latin typeface="Calibri"/>
                         <a:cs typeface="Calibri"/>
                       </a:endParaRPr>
@@ -6447,7 +6447,7 @@
                     <a:bodyPr/>
                     <a:lstStyle/>
                     <a:p>
-                      <a:pPr marL="744220">
+                      <a:pPr marL="179388" indent="0">
                         <a:lnSpc>
                           <a:spcPct val="100000"/>
                         </a:lnSpc>
@@ -6456,13 +6456,13 @@
                         </a:spcBef>
                       </a:pPr>
                       <a:r>
-                        <a:rPr lang="en-US" sz="2000" b="1" spc="-10" dirty="0" err="1" smtClean="0">
+                        <a:rPr lang="en-US" sz="2400" b="1" spc="-10" dirty="0" err="1" smtClean="0">
                           <a:latin typeface="Calibri"/>
                           <a:cs typeface="Calibri"/>
                         </a:rPr>
                         <a:t>Roboflow</a:t>
                       </a:r>
-                      <a:endParaRPr sz="2000" dirty="0">
+                      <a:endParaRPr sz="2400" dirty="0">
                         <a:latin typeface="Calibri"/>
                         <a:cs typeface="Calibri"/>
                       </a:endParaRPr>
@@ -6509,13 +6509,13 @@
                         </a:spcBef>
                       </a:pPr>
                       <a:r>
-                        <a:rPr lang="en-US" sz="2000" b="1" spc="-10" dirty="0" smtClean="0">
+                        <a:rPr lang="en-US" sz="2400" b="1" spc="-10" dirty="0" smtClean="0">
                           <a:latin typeface="Calibri"/>
                           <a:cs typeface="Calibri"/>
                         </a:rPr>
                         <a:t>Google Lens</a:t>
                       </a:r>
-                      <a:endParaRPr sz="2000" dirty="0">
+                      <a:endParaRPr sz="2400" dirty="0">
                         <a:latin typeface="Calibri"/>
                         <a:cs typeface="Calibri"/>
                       </a:endParaRPr>
@@ -6553,7 +6553,7 @@
                     <a:bodyPr/>
                     <a:lstStyle/>
                     <a:p>
-                      <a:pPr marL="418465">
+                      <a:pPr marL="268288" indent="0">
                         <a:lnSpc>
                           <a:spcPct val="100000"/>
                         </a:lnSpc>
@@ -6562,20 +6562,20 @@
                         </a:spcBef>
                       </a:pPr>
                       <a:r>
-                        <a:rPr lang="en-US" sz="2000" b="1" spc="-10" dirty="0" err="1" smtClean="0">
+                        <a:rPr lang="en-US" sz="2400" b="1" spc="-10" dirty="0" err="1" smtClean="0">
                           <a:latin typeface="Calibri"/>
                           <a:cs typeface="Calibri"/>
                         </a:rPr>
                         <a:t>Detectron</a:t>
                       </a:r>
                       <a:r>
-                        <a:rPr lang="en-US" sz="2000" b="1" spc="-10" dirty="0" smtClean="0">
+                        <a:rPr lang="en-US" sz="2400" b="1" spc="-10" dirty="0" smtClean="0">
                           <a:latin typeface="Calibri"/>
                           <a:cs typeface="Calibri"/>
                         </a:rPr>
                         <a:t> 2</a:t>
                       </a:r>
-                      <a:endParaRPr sz="2000" dirty="0">
+                      <a:endParaRPr sz="2400" dirty="0">
                         <a:latin typeface="Calibri"/>
                         <a:cs typeface="Calibri"/>
                       </a:endParaRPr>
@@ -6613,7 +6613,7 @@
                     <a:bodyPr/>
                     <a:lstStyle/>
                     <a:p>
-                      <a:pPr marL="607695">
+                      <a:pPr marL="179388" indent="0">
                         <a:lnSpc>
                           <a:spcPct val="100000"/>
                         </a:lnSpc>
@@ -6622,13 +6622,13 @@
                         </a:spcBef>
                       </a:pPr>
                       <a:r>
-                        <a:rPr lang="en-US" sz="2000" b="1" spc="-10" dirty="0" smtClean="0">
+                        <a:rPr lang="en-US" sz="2400" b="1" spc="-10" dirty="0" smtClean="0">
                           <a:latin typeface="Calibri"/>
                           <a:cs typeface="Calibri"/>
                         </a:rPr>
                         <a:t>Vision Pro AI</a:t>
                       </a:r>
-                      <a:endParaRPr sz="2000" dirty="0">
+                      <a:endParaRPr sz="2400" dirty="0">
                         <a:latin typeface="Calibri"/>
                         <a:cs typeface="Calibri"/>
                       </a:endParaRPr>
@@ -6682,13 +6682,13 @@
                         </a:spcBef>
                       </a:pPr>
                       <a:r>
-                        <a:rPr lang="ru-RU" sz="2000" spc="-10" dirty="0" smtClean="0">
+                        <a:rPr lang="ru-RU" sz="2400" spc="-10" dirty="0" smtClean="0">
                           <a:latin typeface="Calibri"/>
                           <a:cs typeface="Calibri"/>
                         </a:rPr>
                         <a:t>Автономная локальная работа</a:t>
                       </a:r>
-                      <a:endParaRPr sz="2000" dirty="0">
+                      <a:endParaRPr sz="2400" dirty="0">
                         <a:latin typeface="Calibri"/>
                         <a:cs typeface="Calibri"/>
                       </a:endParaRPr>
@@ -6735,13 +6735,251 @@
                         </a:spcBef>
                       </a:pPr>
                       <a:r>
-                        <a:rPr lang="ru-RU" sz="2000" spc="-25" dirty="0" smtClean="0">
+                        <a:rPr lang="ru-RU" sz="2400" spc="-25" dirty="0" smtClean="0">
                           <a:latin typeface="Calibri"/>
                           <a:cs typeface="Calibri"/>
                         </a:rPr>
                         <a:t>Нет</a:t>
                       </a:r>
-                      <a:endParaRPr sz="2000" dirty="0">
+                      <a:endParaRPr sz="2400" dirty="0">
+                        <a:latin typeface="Calibri"/>
+                        <a:cs typeface="Calibri"/>
+                      </a:endParaRPr>
+                    </a:p>
+                  </a:txBody>
+                  <a:tcPr marL="0" marR="0" marT="89535" marB="0">
+                    <a:lnL w="12700">
+                      <a:solidFill>
+                        <a:srgbClr val="000000"/>
+                      </a:solidFill>
+                      <a:prstDash val="solid"/>
+                    </a:lnL>
+                    <a:lnR w="12700">
+                      <a:solidFill>
+                        <a:srgbClr val="000000"/>
+                      </a:solidFill>
+                      <a:prstDash val="solid"/>
+                    </a:lnR>
+                    <a:lnT w="12700">
+                      <a:solidFill>
+                        <a:srgbClr val="000000"/>
+                      </a:solidFill>
+                      <a:prstDash val="solid"/>
+                    </a:lnT>
+                    <a:lnB w="12700">
+                      <a:solidFill>
+                        <a:srgbClr val="000000"/>
+                      </a:solidFill>
+                      <a:prstDash val="solid"/>
+                    </a:lnB>
+                    <a:solidFill>
+                      <a:srgbClr val="F54545"/>
+                    </a:solidFill>
+                  </a:tcPr>
+                </a:tc>
+                <a:tc>
+                  <a:txBody>
+                    <a:bodyPr/>
+                    <a:lstStyle/>
+                    <a:p>
+                      <a:pPr marL="68580">
+                        <a:lnSpc>
+                          <a:spcPct val="100000"/>
+                        </a:lnSpc>
+                        <a:spcBef>
+                          <a:spcPts val="705"/>
+                        </a:spcBef>
+                      </a:pPr>
+                      <a:r>
+                        <a:rPr sz="2400" spc="-25" dirty="0">
+                          <a:solidFill>
+                            <a:schemeClr val="tx1"/>
+                          </a:solidFill>
+                          <a:latin typeface="Calibri"/>
+                          <a:ea typeface="+mn-ea"/>
+                          <a:cs typeface="Calibri"/>
+                        </a:rPr>
+                        <a:t>Нет</a:t>
+                      </a:r>
+                    </a:p>
+                  </a:txBody>
+                  <a:tcPr marL="0" marR="0" marT="89535" marB="0">
+                    <a:lnL w="12700">
+                      <a:solidFill>
+                        <a:srgbClr val="000000"/>
+                      </a:solidFill>
+                      <a:prstDash val="solid"/>
+                    </a:lnL>
+                    <a:lnR w="12700">
+                      <a:solidFill>
+                        <a:srgbClr val="000000"/>
+                      </a:solidFill>
+                      <a:prstDash val="solid"/>
+                    </a:lnR>
+                    <a:lnT w="12700">
+                      <a:solidFill>
+                        <a:srgbClr val="000000"/>
+                      </a:solidFill>
+                      <a:prstDash val="solid"/>
+                    </a:lnT>
+                    <a:lnB w="12700">
+                      <a:solidFill>
+                        <a:srgbClr val="000000"/>
+                      </a:solidFill>
+                      <a:prstDash val="solid"/>
+                    </a:lnB>
+                    <a:solidFill>
+                      <a:srgbClr val="F54545"/>
+                    </a:solidFill>
+                  </a:tcPr>
+                </a:tc>
+                <a:tc>
+                  <a:txBody>
+                    <a:bodyPr/>
+                    <a:lstStyle/>
+                    <a:p>
+                      <a:pPr marL="69215">
+                        <a:lnSpc>
+                          <a:spcPct val="100000"/>
+                        </a:lnSpc>
+                        <a:spcBef>
+                          <a:spcPts val="705"/>
+                        </a:spcBef>
+                      </a:pPr>
+                      <a:r>
+                        <a:rPr lang="ru-RU" sz="2400" spc="-25" dirty="0" smtClean="0">
+                          <a:latin typeface="Calibri"/>
+                          <a:cs typeface="Calibri"/>
+                        </a:rPr>
+                        <a:t>Да</a:t>
+                      </a:r>
+                      <a:endParaRPr sz="2400" dirty="0">
+                        <a:latin typeface="Calibri"/>
+                        <a:cs typeface="Calibri"/>
+                      </a:endParaRPr>
+                    </a:p>
+                  </a:txBody>
+                  <a:tcPr marL="0" marR="0" marT="89535" marB="0">
+                    <a:lnL w="12700">
+                      <a:solidFill>
+                        <a:srgbClr val="000000"/>
+                      </a:solidFill>
+                      <a:prstDash val="solid"/>
+                    </a:lnL>
+                    <a:lnR w="12700">
+                      <a:solidFill>
+                        <a:srgbClr val="000000"/>
+                      </a:solidFill>
+                      <a:prstDash val="solid"/>
+                    </a:lnR>
+                    <a:lnT w="12700">
+                      <a:solidFill>
+                        <a:srgbClr val="000000"/>
+                      </a:solidFill>
+                      <a:prstDash val="solid"/>
+                    </a:lnT>
+                    <a:lnB w="12700">
+                      <a:solidFill>
+                        <a:srgbClr val="000000"/>
+                      </a:solidFill>
+                      <a:prstDash val="solid"/>
+                    </a:lnB>
+                    <a:solidFill>
+                      <a:srgbClr val="92D050"/>
+                    </a:solidFill>
+                  </a:tcPr>
+                </a:tc>
+                <a:tc>
+                  <a:txBody>
+                    <a:bodyPr/>
+                    <a:lstStyle/>
+                    <a:p>
+                      <a:pPr marL="69850">
+                        <a:lnSpc>
+                          <a:spcPct val="100000"/>
+                        </a:lnSpc>
+                        <a:spcBef>
+                          <a:spcPts val="705"/>
+                        </a:spcBef>
+                      </a:pPr>
+                      <a:r>
+                        <a:rPr sz="2400" spc="-25" dirty="0">
+                          <a:latin typeface="Calibri"/>
+                          <a:cs typeface="Calibri"/>
+                        </a:rPr>
+                        <a:t>Да</a:t>
+                      </a:r>
+                      <a:endParaRPr sz="2400" dirty="0">
+                        <a:latin typeface="Calibri"/>
+                        <a:cs typeface="Calibri"/>
+                      </a:endParaRPr>
+                    </a:p>
+                  </a:txBody>
+                  <a:tcPr marL="0" marR="0" marT="89535" marB="0">
+                    <a:lnL w="12700">
+                      <a:solidFill>
+                        <a:srgbClr val="000000"/>
+                      </a:solidFill>
+                      <a:prstDash val="solid"/>
+                    </a:lnL>
+                    <a:lnR w="12700">
+                      <a:solidFill>
+                        <a:srgbClr val="000000"/>
+                      </a:solidFill>
+                      <a:prstDash val="solid"/>
+                    </a:lnR>
+                    <a:lnT w="12700">
+                      <a:solidFill>
+                        <a:srgbClr val="000000"/>
+                      </a:solidFill>
+                      <a:prstDash val="solid"/>
+                    </a:lnT>
+                    <a:lnB w="12700">
+                      <a:solidFill>
+                        <a:srgbClr val="000000"/>
+                      </a:solidFill>
+                      <a:prstDash val="solid"/>
+                    </a:lnB>
+                    <a:solidFill>
+                      <a:srgbClr val="92D050"/>
+                    </a:solidFill>
+                  </a:tcPr>
+                </a:tc>
+                <a:extLst>
+                  <a:ext uri="{0D108BD9-81ED-4DB2-BD59-A6C34878D82A}">
+                    <a16:rowId xmlns:a16="http://schemas.microsoft.com/office/drawing/2014/main" val="10001"/>
+                  </a:ext>
+                </a:extLst>
+              </a:tr>
+              <a:tr h="921894">
+                <a:tc>
+                  <a:txBody>
+                    <a:bodyPr/>
+                    <a:lstStyle/>
+                    <a:p>
+                      <a:pPr marL="68580">
+                        <a:lnSpc>
+                          <a:spcPct val="100000"/>
+                        </a:lnSpc>
+                        <a:spcBef>
+                          <a:spcPts val="705"/>
+                        </a:spcBef>
+                      </a:pPr>
+                      <a:r>
+                        <a:rPr lang="ru-RU" sz="2400" spc="-10" dirty="0" smtClean="0">
+                          <a:latin typeface="Calibri"/>
+                          <a:cs typeface="Calibri"/>
+                        </a:rPr>
+                        <a:t>Графический</a:t>
+                      </a:r>
+                      <a:r>
+                        <a:rPr lang="ru-RU" sz="2400" spc="-10" baseline="0" dirty="0" smtClean="0">
+                          <a:latin typeface="Calibri"/>
+                          <a:cs typeface="Calibri"/>
+                        </a:rPr>
+                        <a:t> интерфейс</a:t>
+                      </a:r>
+                      <a:endParaRPr sz="2400" dirty="0">
                         <a:latin typeface="Calibri"/>
                         <a:cs typeface="Calibri"/>
                       </a:endParaRPr>
@@ -6788,13 +7026,13 @@
                         </a:spcBef>
                       </a:pPr>
                       <a:r>
-                        <a:rPr sz="2000" spc="-25" dirty="0">
+                        <a:rPr lang="ru-RU" sz="2400" spc="-25" dirty="0" smtClean="0">
                           <a:latin typeface="Calibri"/>
                           <a:cs typeface="Calibri"/>
                         </a:rPr>
-                        <a:t>Нет</a:t>
+                        <a:t>Да</a:t>
                       </a:r>
-                      <a:endParaRPr sz="2000">
+                      <a:endParaRPr sz="2400" dirty="0">
                         <a:latin typeface="Calibri"/>
                         <a:cs typeface="Calibri"/>
                       </a:endParaRPr>
@@ -6825,6 +7063,65 @@
                       </a:solidFill>
                       <a:prstDash val="solid"/>
                     </a:lnB>
+                    <a:solidFill>
+                      <a:srgbClr val="92D050"/>
+                    </a:solidFill>
+                  </a:tcPr>
+                </a:tc>
+                <a:tc>
+                  <a:txBody>
+                    <a:bodyPr/>
+                    <a:lstStyle/>
+                    <a:p>
+                      <a:pPr marL="68580">
+                        <a:lnSpc>
+                          <a:spcPct val="100000"/>
+                        </a:lnSpc>
+                        <a:spcBef>
+                          <a:spcPts val="705"/>
+                        </a:spcBef>
+                      </a:pPr>
+                      <a:r>
+                        <a:rPr lang="ru-RU" sz="2400" spc="-25" dirty="0" smtClean="0">
+                          <a:latin typeface="Calibri"/>
+                          <a:cs typeface="Calibri"/>
+                        </a:rPr>
+                        <a:t>Да</a:t>
+                      </a:r>
+                      <a:endParaRPr sz="2400" dirty="0">
+                        <a:latin typeface="Calibri"/>
+                        <a:cs typeface="Calibri"/>
+                      </a:endParaRPr>
+                    </a:p>
+                  </a:txBody>
+                  <a:tcPr marL="0" marR="0" marT="89535" marB="0">
+                    <a:lnL w="12700">
+                      <a:solidFill>
+                        <a:srgbClr val="000000"/>
+                      </a:solidFill>
+                      <a:prstDash val="solid"/>
+                    </a:lnL>
+                    <a:lnR w="12700">
+                      <a:solidFill>
+                        <a:srgbClr val="000000"/>
+                      </a:solidFill>
+                      <a:prstDash val="solid"/>
+                    </a:lnR>
+                    <a:lnT w="12700">
+                      <a:solidFill>
+                        <a:srgbClr val="000000"/>
+                      </a:solidFill>
+                      <a:prstDash val="solid"/>
+                    </a:lnT>
+                    <a:lnB w="12700">
+                      <a:solidFill>
+                        <a:srgbClr val="000000"/>
+                      </a:solidFill>
+                      <a:prstDash val="solid"/>
+                    </a:lnB>
+                    <a:solidFill>
+                      <a:srgbClr val="92D050"/>
+                    </a:solidFill>
                   </a:tcPr>
                 </a:tc>
                 <a:tc>
@@ -6841,13 +7138,13 @@
                         </a:spcBef>
                       </a:pPr>
                       <a:r>
-                        <a:rPr lang="ru-RU" sz="2000" spc="-25" dirty="0" smtClean="0">
+                        <a:rPr lang="ru-RU" sz="2400" spc="-25" dirty="0" smtClean="0">
                           <a:latin typeface="Calibri"/>
                           <a:cs typeface="Calibri"/>
                         </a:rPr>
-                        <a:t>Да</a:t>
+                        <a:t>Нет</a:t>
                       </a:r>
-                      <a:endParaRPr sz="2000" dirty="0">
+                      <a:endParaRPr sz="2400" dirty="0">
                         <a:latin typeface="Calibri"/>
                         <a:cs typeface="Calibri"/>
                       </a:endParaRPr>
@@ -6878,6 +7175,9 @@
                       </a:solidFill>
                       <a:prstDash val="solid"/>
                     </a:lnB>
+                    <a:solidFill>
+                      <a:srgbClr val="F54545"/>
+                    </a:solidFill>
                   </a:tcPr>
                 </a:tc>
                 <a:tc>
@@ -6894,13 +7194,13 @@
                         </a:spcBef>
                       </a:pPr>
                       <a:r>
-                        <a:rPr sz="2000" spc="-25" dirty="0">
+                        <a:rPr sz="2400" spc="-25" dirty="0">
                           <a:latin typeface="Calibri"/>
                           <a:cs typeface="Calibri"/>
                         </a:rPr>
                         <a:t>Да</a:t>
                       </a:r>
-                      <a:endParaRPr sz="2000">
+                      <a:endParaRPr sz="2400">
                         <a:latin typeface="Calibri"/>
                         <a:cs typeface="Calibri"/>
                       </a:endParaRPr>
@@ -6931,15 +7231,18 @@
                       </a:solidFill>
                       <a:prstDash val="solid"/>
                     </a:lnB>
+                    <a:solidFill>
+                      <a:srgbClr val="92D050"/>
+                    </a:solidFill>
                   </a:tcPr>
                 </a:tc>
                 <a:extLst>
                   <a:ext uri="{0D108BD9-81ED-4DB2-BD59-A6C34878D82A}">
-                    <a16:rowId xmlns:a16="http://schemas.microsoft.com/office/drawing/2014/main" val="10001"/>
+                    <a16:rowId xmlns:a16="http://schemas.microsoft.com/office/drawing/2014/main" val="10002"/>
                   </a:ext>
                 </a:extLst>
               </a:tr>
-              <a:tr h="1323975">
+              <a:tr h="893319">
                 <a:tc>
                   <a:txBody>
                     <a:bodyPr/>
@@ -6954,20 +7257,13 @@
                         </a:spcBef>
                       </a:pPr>
                       <a:r>
-                        <a:rPr lang="ru-RU" sz="2000" spc="-10" dirty="0" smtClean="0">
+                        <a:rPr lang="ru-RU" sz="2400" spc="-10" dirty="0" smtClean="0">
                           <a:latin typeface="Calibri"/>
                           <a:cs typeface="Calibri"/>
                         </a:rPr>
-                        <a:t>Графический</a:t>
+                        <a:t>Кастомная детекция объектов</a:t>
                       </a:r>
-                      <a:r>
-                        <a:rPr lang="ru-RU" sz="2000" spc="-10" baseline="0" dirty="0" smtClean="0">
-                          <a:latin typeface="Calibri"/>
-                          <a:cs typeface="Calibri"/>
-                        </a:rPr>
-                        <a:t> интерфейс</a:t>
-                      </a:r>
-                      <a:endParaRPr sz="2000" dirty="0">
+                      <a:endParaRPr sz="2400" dirty="0">
                         <a:latin typeface="Calibri"/>
                         <a:cs typeface="Calibri"/>
                       </a:endParaRPr>
@@ -7014,13 +7310,13 @@
                         </a:spcBef>
                       </a:pPr>
                       <a:r>
-                        <a:rPr lang="ru-RU" sz="2000" spc="-25" dirty="0" smtClean="0">
+                        <a:rPr sz="2400" spc="-25" dirty="0">
                           <a:latin typeface="Calibri"/>
                           <a:cs typeface="Calibri"/>
                         </a:rPr>
                         <a:t>Да</a:t>
                       </a:r>
-                      <a:endParaRPr sz="2000" dirty="0">
+                      <a:endParaRPr sz="2400" dirty="0">
                         <a:latin typeface="Calibri"/>
                         <a:cs typeface="Calibri"/>
                       </a:endParaRPr>
@@ -7051,6 +7347,9 @@
                       </a:solidFill>
                       <a:prstDash val="solid"/>
                     </a:lnB>
+                    <a:solidFill>
+                      <a:srgbClr val="92D050"/>
+                    </a:solidFill>
                   </a:tcPr>
                 </a:tc>
                 <a:tc>
@@ -7067,13 +7366,13 @@
                         </a:spcBef>
                       </a:pPr>
                       <a:r>
-                        <a:rPr lang="ru-RU" sz="2000" spc="-25" dirty="0" smtClean="0">
+                        <a:rPr lang="ru-RU" sz="2400" spc="-25" dirty="0" smtClean="0">
                           <a:latin typeface="Calibri"/>
                           <a:cs typeface="Calibri"/>
                         </a:rPr>
-                        <a:t>Да</a:t>
+                        <a:t>Нет</a:t>
                       </a:r>
-                      <a:endParaRPr sz="2000" dirty="0">
+                      <a:endParaRPr sz="2400" dirty="0">
                         <a:latin typeface="Calibri"/>
                         <a:cs typeface="Calibri"/>
                       </a:endParaRPr>
@@ -7104,6 +7403,9 @@
                       </a:solidFill>
                       <a:prstDash val="solid"/>
                     </a:lnB>
+                    <a:solidFill>
+                      <a:srgbClr val="F54545"/>
+                    </a:solidFill>
                   </a:tcPr>
                 </a:tc>
                 <a:tc>
@@ -7120,13 +7422,13 @@
                         </a:spcBef>
                       </a:pPr>
                       <a:r>
-                        <a:rPr lang="ru-RU" sz="2000" spc="-25" dirty="0" smtClean="0">
+                        <a:rPr sz="2400" spc="-25" dirty="0">
                           <a:latin typeface="Calibri"/>
                           <a:cs typeface="Calibri"/>
                         </a:rPr>
-                        <a:t>Нет</a:t>
+                        <a:t>Да</a:t>
                       </a:r>
-                      <a:endParaRPr sz="2000" dirty="0">
+                      <a:endParaRPr sz="2400" dirty="0">
                         <a:latin typeface="Calibri"/>
                         <a:cs typeface="Calibri"/>
                       </a:endParaRPr>
@@ -7157,6 +7459,9 @@
                       </a:solidFill>
                       <a:prstDash val="solid"/>
                     </a:lnB>
+                    <a:solidFill>
+                      <a:srgbClr val="92D050"/>
+                    </a:solidFill>
                   </a:tcPr>
                 </a:tc>
                 <a:tc>
@@ -7173,13 +7478,13 @@
                         </a:spcBef>
                       </a:pPr>
                       <a:r>
-                        <a:rPr sz="2000" spc="-25" dirty="0">
+                        <a:rPr sz="2400" spc="-25" dirty="0">
                           <a:latin typeface="Calibri"/>
                           <a:cs typeface="Calibri"/>
                         </a:rPr>
                         <a:t>Да</a:t>
                       </a:r>
-                      <a:endParaRPr sz="2000">
+                      <a:endParaRPr sz="2400" dirty="0">
                         <a:latin typeface="Calibri"/>
                         <a:cs typeface="Calibri"/>
                       </a:endParaRPr>
@@ -7210,278 +7515,9 @@
                       </a:solidFill>
                       <a:prstDash val="solid"/>
                     </a:lnB>
-                  </a:tcPr>
-                </a:tc>
-                <a:extLst>
-                  <a:ext uri="{0D108BD9-81ED-4DB2-BD59-A6C34878D82A}">
-                    <a16:rowId xmlns:a16="http://schemas.microsoft.com/office/drawing/2014/main" val="10002"/>
-                  </a:ext>
-                </a:extLst>
-              </a:tr>
-              <a:tr h="1323975">
-                <a:tc>
-                  <a:txBody>
-                    <a:bodyPr/>
-                    <a:lstStyle/>
-                    <a:p>
-                      <a:pPr marL="68580">
-                        <a:lnSpc>
-                          <a:spcPct val="100000"/>
-                        </a:lnSpc>
-                        <a:spcBef>
-                          <a:spcPts val="705"/>
-                        </a:spcBef>
-                      </a:pPr>
-                      <a:r>
-                        <a:rPr lang="ru-RU" sz="2000" spc="-10" dirty="0" smtClean="0">
-                          <a:latin typeface="Calibri"/>
-                          <a:cs typeface="Calibri"/>
-                        </a:rPr>
-                        <a:t>Кастомная детекция объектов</a:t>
-                      </a:r>
-                      <a:endParaRPr sz="2000" dirty="0">
-                        <a:latin typeface="Calibri"/>
-                        <a:cs typeface="Calibri"/>
-                      </a:endParaRPr>
-                    </a:p>
-                  </a:txBody>
-                  <a:tcPr marL="0" marR="0" marT="89535" marB="0">
-                    <a:lnL w="12700">
-                      <a:solidFill>
-                        <a:srgbClr val="000000"/>
-                      </a:solidFill>
-                      <a:prstDash val="solid"/>
-                    </a:lnL>
-                    <a:lnR w="12700">
-                      <a:solidFill>
-                        <a:srgbClr val="000000"/>
-                      </a:solidFill>
-                      <a:prstDash val="solid"/>
-                    </a:lnR>
-                    <a:lnT w="12700">
-                      <a:solidFill>
-                        <a:srgbClr val="000000"/>
-                      </a:solidFill>
-                      <a:prstDash val="solid"/>
-                    </a:lnT>
-                    <a:lnB w="12700">
-                      <a:solidFill>
-                        <a:srgbClr val="000000"/>
-                      </a:solidFill>
-                      <a:prstDash val="solid"/>
-                    </a:lnB>
-                  </a:tcPr>
-                </a:tc>
-                <a:tc>
-                  <a:txBody>
-                    <a:bodyPr/>
-                    <a:lstStyle/>
-                    <a:p>
-                      <a:pPr marL="68580">
-                        <a:lnSpc>
-                          <a:spcPct val="100000"/>
-                        </a:lnSpc>
-                        <a:spcBef>
-                          <a:spcPts val="705"/>
-                        </a:spcBef>
-                      </a:pPr>
-                      <a:r>
-                        <a:rPr sz="2000" spc="-25" dirty="0">
-                          <a:latin typeface="Calibri"/>
-                          <a:cs typeface="Calibri"/>
-                        </a:rPr>
-                        <a:t>Да</a:t>
-                      </a:r>
-                      <a:endParaRPr sz="2000">
-                        <a:latin typeface="Calibri"/>
-                        <a:cs typeface="Calibri"/>
-                      </a:endParaRPr>
-                    </a:p>
-                  </a:txBody>
-                  <a:tcPr marL="0" marR="0" marT="89535" marB="0">
-                    <a:lnL w="12700">
-                      <a:solidFill>
-                        <a:srgbClr val="000000"/>
-                      </a:solidFill>
-                      <a:prstDash val="solid"/>
-                    </a:lnL>
-                    <a:lnR w="12700">
-                      <a:solidFill>
-                        <a:srgbClr val="000000"/>
-                      </a:solidFill>
-                      <a:prstDash val="solid"/>
-                    </a:lnR>
-                    <a:lnT w="12700">
-                      <a:solidFill>
-                        <a:srgbClr val="000000"/>
-                      </a:solidFill>
-                      <a:prstDash val="solid"/>
-                    </a:lnT>
-                    <a:lnB w="12700">
-                      <a:solidFill>
-                        <a:srgbClr val="000000"/>
-                      </a:solidFill>
-                      <a:prstDash val="solid"/>
-                    </a:lnB>
-                  </a:tcPr>
-                </a:tc>
-                <a:tc>
-                  <a:txBody>
-                    <a:bodyPr/>
-                    <a:lstStyle/>
-                    <a:p>
-                      <a:pPr marL="68580">
-                        <a:lnSpc>
-                          <a:spcPct val="100000"/>
-                        </a:lnSpc>
-                        <a:spcBef>
-                          <a:spcPts val="705"/>
-                        </a:spcBef>
-                      </a:pPr>
-                      <a:r>
-                        <a:rPr lang="ru-RU" sz="2000" spc="-25" dirty="0" smtClean="0">
-                          <a:latin typeface="Calibri"/>
-                          <a:cs typeface="Calibri"/>
-                        </a:rPr>
-                        <a:t>Нет</a:t>
-                      </a:r>
-                      <a:endParaRPr sz="2000" dirty="0">
-                        <a:latin typeface="Calibri"/>
-                        <a:cs typeface="Calibri"/>
-                      </a:endParaRPr>
-                    </a:p>
-                  </a:txBody>
-                  <a:tcPr marL="0" marR="0" marT="89535" marB="0">
-                    <a:lnL w="12700">
-                      <a:solidFill>
-                        <a:srgbClr val="000000"/>
-                      </a:solidFill>
-                      <a:prstDash val="solid"/>
-                    </a:lnL>
-                    <a:lnR w="12700">
-                      <a:solidFill>
-                        <a:srgbClr val="000000"/>
-                      </a:solidFill>
-                      <a:prstDash val="solid"/>
-                    </a:lnR>
-                    <a:lnT w="12700">
-                      <a:solidFill>
-                        <a:srgbClr val="000000"/>
-                      </a:solidFill>
-                      <a:prstDash val="solid"/>
-                    </a:lnT>
-                    <a:lnB w="12700">
-                      <a:solidFill>
-                        <a:srgbClr val="000000"/>
-                      </a:solidFill>
-                      <a:prstDash val="solid"/>
-                    </a:lnB>
-                  </a:tcPr>
-                </a:tc>
-                <a:tc>
-                  <a:txBody>
-                    <a:bodyPr/>
-                    <a:lstStyle/>
-                    <a:p>
-                      <a:pPr marL="69215">
-                        <a:lnSpc>
-                          <a:spcPct val="100000"/>
-                        </a:lnSpc>
-                        <a:spcBef>
-                          <a:spcPts val="705"/>
-                        </a:spcBef>
-                      </a:pPr>
-                      <a:r>
-                        <a:rPr sz="2000" spc="-25" dirty="0">
-                          <a:latin typeface="Calibri"/>
-                          <a:cs typeface="Calibri"/>
-                        </a:rPr>
-                        <a:t>Да</a:t>
-                      </a:r>
-                      <a:endParaRPr sz="2000">
-                        <a:latin typeface="Calibri"/>
-                        <a:cs typeface="Calibri"/>
-                      </a:endParaRPr>
-                    </a:p>
-                  </a:txBody>
-                  <a:tcPr marL="0" marR="0" marT="89535" marB="0">
-                    <a:lnL w="12700">
-                      <a:solidFill>
-                        <a:srgbClr val="000000"/>
-                      </a:solidFill>
-                      <a:prstDash val="solid"/>
-                    </a:lnL>
-                    <a:lnR w="12700">
-                      <a:solidFill>
-                        <a:srgbClr val="000000"/>
-                      </a:solidFill>
-                      <a:prstDash val="solid"/>
-                    </a:lnR>
-                    <a:lnT w="12700">
-                      <a:solidFill>
-                        <a:srgbClr val="000000"/>
-                      </a:solidFill>
-                      <a:prstDash val="solid"/>
-                    </a:lnT>
-                    <a:lnB w="12700">
-                      <a:solidFill>
-                        <a:srgbClr val="000000"/>
-                      </a:solidFill>
-                      <a:prstDash val="solid"/>
-                    </a:lnB>
-                  </a:tcPr>
-                </a:tc>
-                <a:tc>
-                  <a:txBody>
-                    <a:bodyPr/>
-                    <a:lstStyle/>
-                    <a:p>
-                      <a:pPr marL="69850">
-                        <a:lnSpc>
-                          <a:spcPct val="100000"/>
-                        </a:lnSpc>
-                        <a:spcBef>
-                          <a:spcPts val="705"/>
-                        </a:spcBef>
-                      </a:pPr>
-                      <a:r>
-                        <a:rPr sz="2000" spc="-25" dirty="0">
-                          <a:latin typeface="Calibri"/>
-                          <a:cs typeface="Calibri"/>
-                        </a:rPr>
-                        <a:t>Да</a:t>
-                      </a:r>
-                      <a:endParaRPr sz="2000">
-                        <a:latin typeface="Calibri"/>
-                        <a:cs typeface="Calibri"/>
-                      </a:endParaRPr>
-                    </a:p>
-                  </a:txBody>
-                  <a:tcPr marL="0" marR="0" marT="89535" marB="0">
-                    <a:lnL w="12700">
-                      <a:solidFill>
-                        <a:srgbClr val="000000"/>
-                      </a:solidFill>
-                      <a:prstDash val="solid"/>
-                    </a:lnL>
-                    <a:lnR w="12700">
-                      <a:solidFill>
-                        <a:srgbClr val="000000"/>
-                      </a:solidFill>
-                      <a:prstDash val="solid"/>
-                    </a:lnR>
-                    <a:lnT w="12700">
-                      <a:solidFill>
-                        <a:srgbClr val="000000"/>
-                      </a:solidFill>
-                      <a:prstDash val="solid"/>
-                    </a:lnT>
-                    <a:lnB w="12700">
-                      <a:solidFill>
-                        <a:srgbClr val="000000"/>
-                      </a:solidFill>
-                      <a:prstDash val="solid"/>
-                    </a:lnB>
+                    <a:solidFill>
+                      <a:srgbClr val="92D050"/>
+                    </a:solidFill>
                   </a:tcPr>
                 </a:tc>
                 <a:extLst>
@@ -7505,20 +7541,20 @@
                         </a:spcBef>
                       </a:pPr>
                       <a:r>
-                        <a:rPr lang="ru-RU" sz="2000" spc="-10" dirty="0" smtClean="0">
+                        <a:rPr lang="ru-RU" sz="2400" spc="-10" dirty="0" smtClean="0">
                           <a:latin typeface="Calibri"/>
                           <a:cs typeface="Calibri"/>
                         </a:rPr>
                         <a:t>Локальное</a:t>
                       </a:r>
                       <a:r>
-                        <a:rPr lang="ru-RU" sz="2000" spc="-10" baseline="0" dirty="0" smtClean="0">
+                        <a:rPr lang="ru-RU" sz="2400" spc="-10" baseline="0" dirty="0" smtClean="0">
                           <a:latin typeface="Calibri"/>
                           <a:cs typeface="Calibri"/>
                         </a:rPr>
                         <a:t> сохранение датасетов</a:t>
                       </a:r>
-                      <a:endParaRPr sz="2000" dirty="0">
+                      <a:endParaRPr sz="2400" dirty="0">
                         <a:latin typeface="Calibri"/>
                         <a:cs typeface="Calibri"/>
                       </a:endParaRPr>
@@ -7565,13 +7601,13 @@
                         </a:spcBef>
                       </a:pPr>
                       <a:r>
-                        <a:rPr lang="ru-RU" sz="2000" spc="-25" dirty="0" smtClean="0">
+                        <a:rPr lang="ru-RU" sz="2400" spc="-25" dirty="0" smtClean="0">
                           <a:latin typeface="Calibri"/>
                           <a:cs typeface="Calibri"/>
                         </a:rPr>
                         <a:t>Нет</a:t>
                       </a:r>
-                      <a:endParaRPr sz="2000" dirty="0">
+                      <a:endParaRPr sz="2400" dirty="0">
                         <a:latin typeface="Calibri"/>
                         <a:cs typeface="Calibri"/>
                       </a:endParaRPr>
@@ -7602,6 +7638,9 @@
                       </a:solidFill>
                       <a:prstDash val="solid"/>
                     </a:lnB>
+                    <a:solidFill>
+                      <a:srgbClr val="F54545"/>
+                    </a:solidFill>
                   </a:tcPr>
                 </a:tc>
                 <a:tc>
@@ -7618,13 +7657,13 @@
                         </a:spcBef>
                       </a:pPr>
                       <a:r>
-                        <a:rPr lang="ru-RU" sz="2000" spc="-25" dirty="0" smtClean="0">
+                        <a:rPr lang="ru-RU" sz="2400" spc="-25" dirty="0" smtClean="0">
                           <a:latin typeface="Calibri"/>
                           <a:cs typeface="Calibri"/>
                         </a:rPr>
                         <a:t>Нет</a:t>
                       </a:r>
-                      <a:endParaRPr sz="2000" dirty="0">
+                      <a:endParaRPr sz="2400" dirty="0">
                         <a:latin typeface="Calibri"/>
                         <a:cs typeface="Calibri"/>
                       </a:endParaRPr>
@@ -7655,6 +7694,9 @@
                       </a:solidFill>
                       <a:prstDash val="solid"/>
                     </a:lnB>
+                    <a:solidFill>
+                      <a:srgbClr val="F54545"/>
+                    </a:solidFill>
                   </a:tcPr>
                 </a:tc>
                 <a:tc>
@@ -7671,13 +7713,13 @@
                         </a:spcBef>
                       </a:pPr>
                       <a:r>
-                        <a:rPr sz="2000" spc="-25" dirty="0">
+                        <a:rPr sz="2400" spc="-25" dirty="0">
                           <a:latin typeface="Calibri"/>
                           <a:cs typeface="Calibri"/>
                         </a:rPr>
                         <a:t>Да</a:t>
                       </a:r>
-                      <a:endParaRPr sz="2000">
+                      <a:endParaRPr sz="2400" dirty="0">
                         <a:latin typeface="Calibri"/>
                         <a:cs typeface="Calibri"/>
                       </a:endParaRPr>
@@ -7708,6 +7750,9 @@
                       </a:solidFill>
                       <a:prstDash val="solid"/>
                     </a:lnB>
+                    <a:solidFill>
+                      <a:srgbClr val="92D050"/>
+                    </a:solidFill>
                   </a:tcPr>
                 </a:tc>
                 <a:tc>
@@ -7724,13 +7769,13 @@
                         </a:spcBef>
                       </a:pPr>
                       <a:r>
-                        <a:rPr sz="2000" spc="-25" dirty="0">
+                        <a:rPr sz="2400" spc="-25" dirty="0">
                           <a:latin typeface="Calibri"/>
                           <a:cs typeface="Calibri"/>
                         </a:rPr>
                         <a:t>Да</a:t>
                       </a:r>
-                      <a:endParaRPr sz="2000" dirty="0">
+                      <a:endParaRPr sz="2400" dirty="0">
                         <a:latin typeface="Calibri"/>
                         <a:cs typeface="Calibri"/>
                       </a:endParaRPr>
@@ -7761,6 +7806,9 @@
                       </a:solidFill>
                       <a:prstDash val="solid"/>
                     </a:lnB>
+                    <a:solidFill>
+                      <a:srgbClr val="92D050"/>
+                    </a:solidFill>
                   </a:tcPr>
                 </a:tc>
                 <a:extLst>
@@ -7979,8 +8027,8 @@
         </p:blipFill>
         <p:spPr>
           <a:xfrm>
-            <a:off x="3506589" y="948546"/>
-            <a:ext cx="5178821" cy="5789039"/>
+            <a:off x="3506589" y="1071803"/>
+            <a:ext cx="5178821" cy="5542524"/>
           </a:xfrm>
           <a:prstGeom prst="rect">
             <a:avLst/>
@@ -8197,8 +8245,8 @@
         </p:blipFill>
         <p:spPr>
           <a:xfrm>
-            <a:off x="2880376" y="1259027"/>
-            <a:ext cx="6431245" cy="5041957"/>
+            <a:off x="1295400" y="1245580"/>
+            <a:ext cx="9428059" cy="4989373"/>
           </a:xfrm>
           <a:prstGeom prst="rect">
             <a:avLst/>
@@ -8614,7 +8662,7 @@
         <p:spPr>
           <a:xfrm>
             <a:off x="842645" y="1259027"/>
-            <a:ext cx="10972800" cy="4596771"/>
+            <a:ext cx="10972800" cy="4735271"/>
           </a:xfrm>
           <a:prstGeom prst="rect">
             <a:avLst/>
@@ -8638,75 +8686,75 @@
               </a:tabLst>
             </a:pPr>
             <a:r>
-              <a:rPr lang="ru-RU" sz="2200" dirty="0" smtClean="0">
+              <a:rPr lang="ru-RU" sz="2400" dirty="0" smtClean="0">
                 <a:latin typeface="Calibri"/>
                 <a:cs typeface="Calibri"/>
               </a:rPr>
               <a:t>Среда разработки</a:t>
             </a:r>
             <a:r>
-              <a:rPr lang="en-US" sz="2200" dirty="0" smtClean="0">
+              <a:rPr lang="en-US" sz="2400" dirty="0" smtClean="0">
                 <a:latin typeface="Calibri"/>
                 <a:cs typeface="Calibri"/>
               </a:rPr>
               <a:t> </a:t>
             </a:r>
             <a:r>
-              <a:rPr lang="ru-RU" sz="2200" dirty="0" smtClean="0">
+              <a:rPr lang="ru-RU" sz="2400" dirty="0" smtClean="0">
                 <a:latin typeface="Calibri"/>
                 <a:cs typeface="Calibri"/>
               </a:rPr>
               <a:t>- </a:t>
             </a:r>
             <a:r>
-              <a:rPr lang="en-US" sz="2200" dirty="0" err="1" smtClean="0">
+              <a:rPr lang="en-US" sz="2400" dirty="0" err="1" smtClean="0">
                 <a:latin typeface="Calibri"/>
                 <a:cs typeface="Calibri"/>
               </a:rPr>
               <a:t>JetBrains</a:t>
             </a:r>
             <a:r>
-              <a:rPr lang="en-US" sz="2200" dirty="0" smtClean="0">
+              <a:rPr lang="en-US" sz="2400" dirty="0" smtClean="0">
                 <a:latin typeface="Calibri"/>
                 <a:cs typeface="Calibri"/>
               </a:rPr>
               <a:t> </a:t>
             </a:r>
             <a:r>
-              <a:rPr lang="en-US" sz="2200" dirty="0" err="1" smtClean="0">
+              <a:rPr lang="en-US" sz="2400" dirty="0" err="1" smtClean="0">
                 <a:latin typeface="Calibri"/>
                 <a:cs typeface="Calibri"/>
               </a:rPr>
               <a:t>PyCharm</a:t>
             </a:r>
             <a:r>
-              <a:rPr lang="ru-RU" sz="2200" dirty="0">
+              <a:rPr lang="ru-RU" sz="2400" dirty="0">
                 <a:latin typeface="Calibri"/>
                 <a:cs typeface="Calibri"/>
               </a:rPr>
               <a:t/>
             </a:r>
             <a:br>
-              <a:rPr lang="ru-RU" sz="2200" dirty="0">
+              <a:rPr lang="ru-RU" sz="2400" dirty="0">
                 <a:latin typeface="Calibri"/>
                 <a:cs typeface="Calibri"/>
               </a:rPr>
             </a:br>
             <a:r>
-              <a:rPr lang="ru-RU" sz="2200" dirty="0" smtClean="0">
+              <a:rPr lang="ru-RU" sz="2400" dirty="0" smtClean="0">
                 <a:latin typeface="Calibri"/>
                 <a:cs typeface="Calibri"/>
               </a:rPr>
               <a:t>Язык программирования - </a:t>
             </a:r>
             <a:r>
-              <a:rPr lang="en-US" sz="2200" dirty="0" smtClean="0">
+              <a:rPr lang="en-US" sz="2400" dirty="0" smtClean="0">
                 <a:latin typeface="Calibri"/>
                 <a:cs typeface="Calibri"/>
               </a:rPr>
               <a:t>Python v3.12.5 </a:t>
             </a:r>
-            <a:endParaRPr lang="ru-RU" sz="2200" dirty="0" smtClean="0">
+            <a:endParaRPr lang="ru-RU" sz="2400" dirty="0" smtClean="0">
               <a:latin typeface="Calibri"/>
               <a:cs typeface="Calibri"/>
             </a:endParaRPr>
@@ -8724,13 +8772,13 @@
               </a:tabLst>
             </a:pPr>
             <a:r>
-              <a:rPr lang="ru-RU" sz="2200" dirty="0" smtClean="0">
+              <a:rPr lang="ru-RU" sz="2400" dirty="0" smtClean="0">
                 <a:latin typeface="Calibri"/>
                 <a:cs typeface="Calibri"/>
               </a:rPr>
               <a:t>Библиотеки используемые в проекте:</a:t>
             </a:r>
-            <a:endParaRPr lang="en-US" sz="2200" dirty="0" smtClean="0">
+            <a:endParaRPr lang="en-US" sz="2400" dirty="0" smtClean="0">
               <a:latin typeface="Calibri"/>
               <a:cs typeface="Calibri"/>
             </a:endParaRPr>

</xml_diff>